<commit_message>
🎨 ENRICHISSEMENT FINAL: 6 PPTX enrichis (3,7,9,11,13,14 → 9-12 slides avec Merise+GESCOM) + toggle sandbox
</commit_message>
<xml_diff>
--- a/pptx/Module09_CREATE_DATABASE_et_TABLE.pptx
+++ b/pptx/Module09_CREATE_DATABASE_et_TABLE.pptx
@@ -598,7 +598,7 @@
           <a:p>
             <a:r>
               <a:rPr lang="en-US" dirty="0"/>
-              <a:t>DDL vs DML : DDL modifie la STRUCTURE, DML modifie les DONNÉES.</a:t>
+              <a:t>Bien distinguer DDL (structure) vs DML (donnees).</a:t>
             </a:r>
             <a:endParaRPr lang="en-US" dirty="0"/>
           </a:p>
@@ -686,7 +686,7 @@
           <a:p>
             <a:r>
               <a:rPr lang="en-US" dirty="0"/>
-              <a:t>Décortiquer chaque ligne : type, contrainte, default. Faire taper aux étudiants dans HeidiSQL.</a:t>
+              <a:t>Decortiquer chaque ligne. Faire taper aux etudiants dans HeidiSQL.</a:t>
             </a:r>
             <a:endParaRPr lang="en-US" dirty="0"/>
           </a:p>
@@ -774,7 +774,7 @@
           <a:p>
             <a:r>
               <a:rPr lang="en-US" dirty="0"/>
-              <a:t>Expliquer ON DELETE RESTRICT = on ne peut pas supprimer un artiste qui a des albums. ON UPDATE CASCADE = si on change l'id artiste, ça se propage.</a:t>
+              <a:t>ON DELETE RESTRICT vs CASCADE : le choix depend du METIER.</a:t>
             </a:r>
             <a:endParaRPr lang="en-US" dirty="0"/>
           </a:p>
@@ -862,7 +862,7 @@
           <a:p>
             <a:r>
               <a:rPr lang="en-US" dirty="0"/>
-              <a:t>Erreur classique : essayer de créer session avant salle → erreur 1215. L'ordre est crucial.</a:t>
+              <a:t>Erreur classique : creer session avant salle → erreur 1215.</a:t>
             </a:r>
             <a:endParaRPr lang="en-US" dirty="0"/>
           </a:p>
@@ -950,7 +950,7 @@
           <a:p>
             <a:r>
               <a:rPr lang="en-US" dirty="0"/>
-              <a:t>Ces conventions facilitent la maintenance et la lisibilité.</a:t>
+              <a:t>Ces conventions facilitent la maintenance.</a:t>
             </a:r>
             <a:endParaRPr lang="en-US" dirty="0"/>
           </a:p>
@@ -1038,7 +1038,7 @@
           <a:p>
             <a:r>
               <a:rPr lang="en-US" dirty="0"/>
-              <a:t>Script complet fourni dans sql/00_swisssound_create.sql. Les étudiants doivent le taper eux-mêmes.</a:t>
+              <a:t>Les etudiants tapent le script eux-memes, pas de copier-coller.</a:t>
             </a:r>
             <a:endParaRPr lang="en-US" dirty="0"/>
           </a:p>
@@ -1695,7 +1695,7 @@
               <a:buNone/>
             </a:pPr>
             <a:r>
-              <a:rPr lang="en-US" sz="3200" b="1" dirty="0">
+              <a:rPr lang="en-US" sz="2800" b="1" dirty="0">
                 <a:solidFill>
                   <a:srgbClr val="FFFFFF"/>
                 </a:solidFill>
@@ -1705,7 +1705,7 @@
               </a:rPr>
               <a:t>CREATE DATABASE et TABLE</a:t>
             </a:r>
-            <a:endParaRPr lang="en-US" sz="3200" dirty="0"/>
+            <a:endParaRPr lang="en-US" sz="2800" dirty="0"/>
           </a:p>
         </p:txBody>
       </p:sp>
@@ -1734,7 +1734,7 @@
               <a:buNone/>
             </a:pPr>
             <a:r>
-              <a:rPr lang="en-US" sz="1500" dirty="0">
+              <a:rPr lang="en-US" sz="1400" dirty="0">
                 <a:solidFill>
                   <a:srgbClr val="CCCCCC"/>
                 </a:solidFill>
@@ -1742,9 +1742,9 @@
                 <a:ea typeface="Calibri" pitchFamily="34" charset="-122"/>
                 <a:cs typeface="Calibri" pitchFamily="34" charset="-120"/>
               </a:rPr>
-              <a:t>DDL · Types MySQL · Ordre de création FK</a:t>
-            </a:r>
-            <a:endParaRPr lang="en-US" sz="1500" dirty="0"/>
+              <a:t>DDL, types MySQL, ordre de creation FK, contraintes</a:t>
+            </a:r>
+            <a:endParaRPr lang="en-US" sz="1400" dirty="0"/>
           </a:p>
         </p:txBody>
       </p:sp>
@@ -1848,7 +1848,7 @@
         <p:spPr>
           <a:xfrm>
             <a:off x="457200" y="182880"/>
-            <a:ext cx="8229600" cy="594360"/>
+            <a:ext cx="8229600" cy="502920"/>
           </a:xfrm>
           <a:prstGeom prst="rect">
             <a:avLst/>
@@ -1864,7 +1864,7 @@
               <a:buNone/>
             </a:pPr>
             <a:r>
-              <a:rPr lang="en-US" sz="2400" b="1" dirty="0">
+              <a:rPr lang="en-US" sz="2100" b="1" dirty="0">
                 <a:solidFill>
                   <a:srgbClr val="0D47A1"/>
                 </a:solidFill>
@@ -1874,7 +1874,7 @@
               </a:rPr>
               <a:t>DDL : Data Definition Language</a:t>
             </a:r>
-            <a:endParaRPr lang="en-US" sz="2400" dirty="0"/>
+            <a:endParaRPr lang="en-US" sz="2100" dirty="0"/>
           </a:p>
         </p:txBody>
       </p:sp>
@@ -1886,8 +1886,8 @@
         </p:nvSpPr>
         <p:spPr>
           <a:xfrm>
-            <a:off x="457200" y="914400"/>
-            <a:ext cx="8229600" cy="464058"/>
+            <a:off x="457200" y="777240"/>
+            <a:ext cx="8229600" cy="448056"/>
           </a:xfrm>
           <a:prstGeom prst="rect">
             <a:avLst/>
@@ -1896,13 +1896,6 @@
             <a:srgbClr val="FFFFFF"/>
           </a:solidFill>
           <a:ln/>
-          <a:effectLst>
-            <a:outerShdw sx="100000" sy="100000" kx="0" ky="0" algn="bl" rotWithShape="0" blurRad="50800" dist="25400" dir="8100000">
-              <a:srgbClr val="000000">
-                <a:alpha val="12000"/>
-              </a:srgbClr>
-            </a:outerShdw>
-          </a:effectLst>
         </p:spPr>
       </p:sp>
       <p:sp>
@@ -1913,8 +1906,8 @@
         </p:nvSpPr>
         <p:spPr>
           <a:xfrm>
-            <a:off x="457200" y="914400"/>
-            <a:ext cx="45720" cy="464058"/>
+            <a:off x="457200" y="777240"/>
+            <a:ext cx="45720" cy="448056"/>
           </a:xfrm>
           <a:prstGeom prst="rect">
             <a:avLst/>
@@ -1933,8 +1926,8 @@
         </p:nvSpPr>
         <p:spPr>
           <a:xfrm>
-            <a:off x="685800" y="914400"/>
-            <a:ext cx="7818120" cy="464058"/>
+            <a:off x="640080" y="777240"/>
+            <a:ext cx="7863840" cy="448056"/>
           </a:xfrm>
           <a:prstGeom prst="rect">
             <a:avLst/>
@@ -1950,7 +1943,7 @@
               <a:buNone/>
             </a:pPr>
             <a:r>
-              <a:rPr lang="en-US" sz="1200" dirty="0">
+              <a:rPr lang="en-US" sz="1100" dirty="0">
                 <a:solidFill>
                   <a:srgbClr val="1A1A2E"/>
                 </a:solidFill>
@@ -1958,9 +1951,9 @@
                 <a:ea typeface="Calibri" pitchFamily="34" charset="-122"/>
                 <a:cs typeface="Calibri" pitchFamily="34" charset="-120"/>
               </a:rPr>
-              <a:t>DDL = commandes qui DÉFINISSENT la structure de la BDD</a:t>
-            </a:r>
-            <a:endParaRPr lang="en-US" sz="1200" dirty="0"/>
+              <a:t>DDL = commandes qui DEFINISSENT la structure</a:t>
+            </a:r>
+            <a:endParaRPr lang="en-US" sz="1100" dirty="0"/>
           </a:p>
         </p:txBody>
       </p:sp>
@@ -1972,8 +1965,8 @@
         </p:nvSpPr>
         <p:spPr>
           <a:xfrm>
-            <a:off x="457200" y="1405890"/>
-            <a:ext cx="8229600" cy="464058"/>
+            <a:off x="457200" y="1252728"/>
+            <a:ext cx="8229600" cy="448056"/>
           </a:xfrm>
           <a:prstGeom prst="rect">
             <a:avLst/>
@@ -1982,13 +1975,6 @@
             <a:srgbClr val="E3F2FD"/>
           </a:solidFill>
           <a:ln/>
-          <a:effectLst>
-            <a:outerShdw sx="100000" sy="100000" kx="0" ky="0" algn="bl" rotWithShape="0" blurRad="50800" dist="25400" dir="8100000">
-              <a:srgbClr val="000000">
-                <a:alpha val="12000"/>
-              </a:srgbClr>
-            </a:outerShdw>
-          </a:effectLst>
         </p:spPr>
       </p:sp>
       <p:sp>
@@ -1999,8 +1985,8 @@
         </p:nvSpPr>
         <p:spPr>
           <a:xfrm>
-            <a:off x="457200" y="1405890"/>
-            <a:ext cx="45720" cy="464058"/>
+            <a:off x="457200" y="1252728"/>
+            <a:ext cx="45720" cy="448056"/>
           </a:xfrm>
           <a:prstGeom prst="rect">
             <a:avLst/>
@@ -2019,8 +2005,8 @@
         </p:nvSpPr>
         <p:spPr>
           <a:xfrm>
-            <a:off x="685800" y="1405890"/>
-            <a:ext cx="7818120" cy="464058"/>
+            <a:off x="640080" y="1252728"/>
+            <a:ext cx="7863840" cy="448056"/>
           </a:xfrm>
           <a:prstGeom prst="rect">
             <a:avLst/>
@@ -2058,8 +2044,8 @@
         </p:nvSpPr>
         <p:spPr>
           <a:xfrm>
-            <a:off x="457200" y="1897380"/>
-            <a:ext cx="8229600" cy="464058"/>
+            <a:off x="457200" y="1728216"/>
+            <a:ext cx="8229600" cy="448056"/>
           </a:xfrm>
           <a:prstGeom prst="rect">
             <a:avLst/>
@@ -2068,13 +2054,6 @@
             <a:srgbClr val="FFFFFF"/>
           </a:solidFill>
           <a:ln/>
-          <a:effectLst>
-            <a:outerShdw sx="100000" sy="100000" kx="0" ky="0" algn="bl" rotWithShape="0" blurRad="50800" dist="25400" dir="8100000">
-              <a:srgbClr val="000000">
-                <a:alpha val="12000"/>
-              </a:srgbClr>
-            </a:outerShdw>
-          </a:effectLst>
         </p:spPr>
       </p:sp>
       <p:sp>
@@ -2085,8 +2064,8 @@
         </p:nvSpPr>
         <p:spPr>
           <a:xfrm>
-            <a:off x="457200" y="1897380"/>
-            <a:ext cx="45720" cy="464058"/>
+            <a:off x="457200" y="1728216"/>
+            <a:ext cx="45720" cy="448056"/>
           </a:xfrm>
           <a:prstGeom prst="rect">
             <a:avLst/>
@@ -2105,8 +2084,8 @@
         </p:nvSpPr>
         <p:spPr>
           <a:xfrm>
-            <a:off x="685800" y="1897380"/>
-            <a:ext cx="7818120" cy="464058"/>
+            <a:off x="640080" y="1728216"/>
+            <a:ext cx="7863840" cy="448056"/>
           </a:xfrm>
           <a:prstGeom prst="rect">
             <a:avLst/>
@@ -2130,7 +2109,7 @@
                 <a:ea typeface="JetBrains Mono" pitchFamily="34" charset="-122"/>
                 <a:cs typeface="JetBrains Mono" pitchFamily="34" charset="-120"/>
               </a:rPr>
-              <a:t>USE swisssound;  -- sélectionner la base active</a:t>
+              <a:t>USE swisssound; — selectionner la base active</a:t>
             </a:r>
             <a:endParaRPr lang="en-US" sz="1000" dirty="0"/>
           </a:p>
@@ -2144,8 +2123,8 @@
         </p:nvSpPr>
         <p:spPr>
           <a:xfrm>
-            <a:off x="457200" y="2388870"/>
-            <a:ext cx="8229600" cy="464058"/>
+            <a:off x="457200" y="2203704"/>
+            <a:ext cx="8229600" cy="448056"/>
           </a:xfrm>
           <a:prstGeom prst="rect">
             <a:avLst/>
@@ -2154,13 +2133,6 @@
             <a:srgbClr val="E3F2FD"/>
           </a:solidFill>
           <a:ln/>
-          <a:effectLst>
-            <a:outerShdw sx="100000" sy="100000" kx="0" ky="0" algn="bl" rotWithShape="0" blurRad="50800" dist="25400" dir="8100000">
-              <a:srgbClr val="000000">
-                <a:alpha val="12000"/>
-              </a:srgbClr>
-            </a:outerShdw>
-          </a:effectLst>
         </p:spPr>
       </p:sp>
       <p:sp>
@@ -2171,8 +2143,8 @@
         </p:nvSpPr>
         <p:spPr>
           <a:xfrm>
-            <a:off x="457200" y="2388870"/>
-            <a:ext cx="45720" cy="464058"/>
+            <a:off x="457200" y="2203704"/>
+            <a:ext cx="45720" cy="448056"/>
           </a:xfrm>
           <a:prstGeom prst="rect">
             <a:avLst/>
@@ -2191,8 +2163,8 @@
         </p:nvSpPr>
         <p:spPr>
           <a:xfrm>
-            <a:off x="685800" y="2388870"/>
-            <a:ext cx="7818120" cy="464058"/>
+            <a:off x="640080" y="2203704"/>
+            <a:ext cx="7863840" cy="448056"/>
           </a:xfrm>
           <a:prstGeom prst="rect">
             <a:avLst/>
@@ -2230,8 +2202,8 @@
         </p:nvSpPr>
         <p:spPr>
           <a:xfrm>
-            <a:off x="457200" y="2880360"/>
-            <a:ext cx="8229600" cy="464058"/>
+            <a:off x="457200" y="2679192"/>
+            <a:ext cx="8229600" cy="448056"/>
           </a:xfrm>
           <a:prstGeom prst="rect">
             <a:avLst/>
@@ -2240,13 +2212,6 @@
             <a:srgbClr val="FFFFFF"/>
           </a:solidFill>
           <a:ln/>
-          <a:effectLst>
-            <a:outerShdw sx="100000" sy="100000" kx="0" ky="0" algn="bl" rotWithShape="0" blurRad="50800" dist="25400" dir="8100000">
-              <a:srgbClr val="000000">
-                <a:alpha val="12000"/>
-              </a:srgbClr>
-            </a:outerShdw>
-          </a:effectLst>
         </p:spPr>
       </p:sp>
       <p:sp>
@@ -2257,8 +2222,8 @@
         </p:nvSpPr>
         <p:spPr>
           <a:xfrm>
-            <a:off x="457200" y="2880360"/>
-            <a:ext cx="45720" cy="464058"/>
+            <a:off x="457200" y="2679192"/>
+            <a:ext cx="45720" cy="448056"/>
           </a:xfrm>
           <a:prstGeom prst="rect">
             <a:avLst/>
@@ -2277,8 +2242,8 @@
         </p:nvSpPr>
         <p:spPr>
           <a:xfrm>
-            <a:off x="685800" y="2880360"/>
-            <a:ext cx="7818120" cy="464058"/>
+            <a:off x="640080" y="2679192"/>
+            <a:ext cx="7863840" cy="448056"/>
           </a:xfrm>
           <a:prstGeom prst="rect">
             <a:avLst/>
@@ -2316,8 +2281,8 @@
         </p:nvSpPr>
         <p:spPr>
           <a:xfrm>
-            <a:off x="457200" y="3371850"/>
-            <a:ext cx="8229600" cy="464058"/>
+            <a:off x="457200" y="3154680"/>
+            <a:ext cx="8229600" cy="448056"/>
           </a:xfrm>
           <a:prstGeom prst="rect">
             <a:avLst/>
@@ -2326,13 +2291,6 @@
             <a:srgbClr val="E3F2FD"/>
           </a:solidFill>
           <a:ln/>
-          <a:effectLst>
-            <a:outerShdw sx="100000" sy="100000" kx="0" ky="0" algn="bl" rotWithShape="0" blurRad="50800" dist="25400" dir="8100000">
-              <a:srgbClr val="000000">
-                <a:alpha val="12000"/>
-              </a:srgbClr>
-            </a:outerShdw>
-          </a:effectLst>
         </p:spPr>
       </p:sp>
       <p:sp>
@@ -2343,8 +2301,8 @@
         </p:nvSpPr>
         <p:spPr>
           <a:xfrm>
-            <a:off x="457200" y="3371850"/>
-            <a:ext cx="45720" cy="464058"/>
+            <a:off x="457200" y="3154680"/>
+            <a:ext cx="45720" cy="448056"/>
           </a:xfrm>
           <a:prstGeom prst="rect">
             <a:avLst/>
@@ -2363,8 +2321,8 @@
         </p:nvSpPr>
         <p:spPr>
           <a:xfrm>
-            <a:off x="685800" y="3371850"/>
-            <a:ext cx="7818120" cy="464058"/>
+            <a:off x="640080" y="3154680"/>
+            <a:ext cx="7863840" cy="448056"/>
           </a:xfrm>
           <a:prstGeom prst="rect">
             <a:avLst/>
@@ -2388,7 +2346,7 @@
                 <a:ea typeface="JetBrains Mono" pitchFamily="34" charset="-122"/>
                 <a:cs typeface="JetBrains Mono" pitchFamily="34" charset="-120"/>
               </a:rPr>
-              <a:t>DROP TABLE IF EXISTS nom_table;  -- suppression</a:t>
+              <a:t>DROP TABLE IF EXISTS nom_table;</a:t>
             </a:r>
             <a:endParaRPr lang="en-US" sz="1000" dirty="0"/>
           </a:p>
@@ -2402,8 +2360,8 @@
         </p:nvSpPr>
         <p:spPr>
           <a:xfrm>
-            <a:off x="457200" y="3863340"/>
-            <a:ext cx="8229600" cy="464058"/>
+            <a:off x="457200" y="3630168"/>
+            <a:ext cx="8229600" cy="448056"/>
           </a:xfrm>
           <a:prstGeom prst="rect">
             <a:avLst/>
@@ -2412,13 +2370,6 @@
             <a:srgbClr val="FFFFFF"/>
           </a:solidFill>
           <a:ln/>
-          <a:effectLst>
-            <a:outerShdw sx="100000" sy="100000" kx="0" ky="0" algn="bl" rotWithShape="0" blurRad="50800" dist="25400" dir="8100000">
-              <a:srgbClr val="000000">
-                <a:alpha val="12000"/>
-              </a:srgbClr>
-            </a:outerShdw>
-          </a:effectLst>
         </p:spPr>
       </p:sp>
       <p:sp>
@@ -2429,8 +2380,8 @@
         </p:nvSpPr>
         <p:spPr>
           <a:xfrm>
-            <a:off x="457200" y="3863340"/>
-            <a:ext cx="45720" cy="464058"/>
+            <a:off x="457200" y="3630168"/>
+            <a:ext cx="45720" cy="448056"/>
           </a:xfrm>
           <a:prstGeom prst="rect">
             <a:avLst/>
@@ -2449,8 +2400,8 @@
         </p:nvSpPr>
         <p:spPr>
           <a:xfrm>
-            <a:off x="685800" y="3863340"/>
-            <a:ext cx="7818120" cy="464058"/>
+            <a:off x="640080" y="3630168"/>
+            <a:ext cx="7863840" cy="448056"/>
           </a:xfrm>
           <a:prstGeom prst="rect">
             <a:avLst/>
@@ -2466,7 +2417,7 @@
               <a:buNone/>
             </a:pPr>
             <a:r>
-              <a:rPr lang="en-US" sz="1200" dirty="0">
+              <a:rPr lang="en-US" sz="1100" dirty="0">
                 <a:solidFill>
                   <a:srgbClr val="1A1A2E"/>
                 </a:solidFill>
@@ -2474,9 +2425,9 @@
                 <a:ea typeface="Calibri" pitchFamily="34" charset="-122"/>
                 <a:cs typeface="Calibri" pitchFamily="34" charset="-120"/>
               </a:rPr>
-              <a:t>SHOW TABLES;  -- lister les tables</a:t>
-            </a:r>
-            <a:endParaRPr lang="en-US" sz="1200" dirty="0"/>
+              <a:t>SHOW TABLES; — lister | SHOW CREATE TABLE artiste; — voir structure</a:t>
+            </a:r>
+            <a:endParaRPr lang="en-US" sz="1100" dirty="0"/>
           </a:p>
         </p:txBody>
       </p:sp>
@@ -2488,8 +2439,8 @@
         </p:nvSpPr>
         <p:spPr>
           <a:xfrm>
-            <a:off x="457200" y="4354830"/>
-            <a:ext cx="8229600" cy="464058"/>
+            <a:off x="457200" y="4105656"/>
+            <a:ext cx="8229600" cy="448056"/>
           </a:xfrm>
           <a:prstGeom prst="rect">
             <a:avLst/>
@@ -2498,13 +2449,6 @@
             <a:srgbClr val="E3F2FD"/>
           </a:solidFill>
           <a:ln/>
-          <a:effectLst>
-            <a:outerShdw sx="100000" sy="100000" kx="0" ky="0" algn="bl" rotWithShape="0" blurRad="50800" dist="25400" dir="8100000">
-              <a:srgbClr val="000000">
-                <a:alpha val="12000"/>
-              </a:srgbClr>
-            </a:outerShdw>
-          </a:effectLst>
         </p:spPr>
       </p:sp>
       <p:sp>
@@ -2515,8 +2459,8 @@
         </p:nvSpPr>
         <p:spPr>
           <a:xfrm>
-            <a:off x="457200" y="4354830"/>
-            <a:ext cx="45720" cy="464058"/>
+            <a:off x="457200" y="4105656"/>
+            <a:ext cx="45720" cy="448056"/>
           </a:xfrm>
           <a:prstGeom prst="rect">
             <a:avLst/>
@@ -2535,8 +2479,8 @@
         </p:nvSpPr>
         <p:spPr>
           <a:xfrm>
-            <a:off x="685800" y="4354830"/>
-            <a:ext cx="7818120" cy="464058"/>
+            <a:off x="640080" y="4105656"/>
+            <a:ext cx="7863840" cy="448056"/>
           </a:xfrm>
           <a:prstGeom prst="rect">
             <a:avLst/>
@@ -2552,7 +2496,7 @@
               <a:buNone/>
             </a:pPr>
             <a:r>
-              <a:rPr lang="en-US" sz="1200" dirty="0">
+              <a:rPr lang="en-US" sz="1100" dirty="0">
                 <a:solidFill>
                   <a:srgbClr val="1A1A2E"/>
                 </a:solidFill>
@@ -2560,9 +2504,9 @@
                 <a:ea typeface="Calibri" pitchFamily="34" charset="-122"/>
                 <a:cs typeface="Calibri" pitchFamily="34" charset="-120"/>
               </a:rPr>
-              <a:t>SHOW CREATE TABLE artiste;  -- voir la structure complète</a:t>
-            </a:r>
-            <a:endParaRPr lang="en-US" sz="1200" dirty="0"/>
+              <a:t>DDL ≠ DML : DDL = structure, DML = donnees</a:t>
+            </a:r>
+            <a:endParaRPr lang="en-US" sz="1100" dirty="0"/>
           </a:p>
         </p:txBody>
       </p:sp>
@@ -2627,7 +2571,7 @@
         <p:spPr>
           <a:xfrm>
             <a:off x="457200" y="182880"/>
-            <a:ext cx="8229600" cy="594360"/>
+            <a:ext cx="8229600" cy="502920"/>
           </a:xfrm>
           <a:prstGeom prst="rect">
             <a:avLst/>
@@ -2643,7 +2587,7 @@
               <a:buNone/>
             </a:pPr>
             <a:r>
-              <a:rPr lang="en-US" sz="2400" b="1" dirty="0">
+              <a:rPr lang="en-US" sz="2100" b="1" dirty="0">
                 <a:solidFill>
                   <a:srgbClr val="0D47A1"/>
                 </a:solidFill>
@@ -2651,9 +2595,9 @@
                 <a:ea typeface="Trebuchet MS" pitchFamily="34" charset="-122"/>
                 <a:cs typeface="Trebuchet MS" pitchFamily="34" charset="-120"/>
               </a:rPr>
-              <a:t>CREATE TABLE — syntaxe complète</a:t>
-            </a:r>
-            <a:endParaRPr lang="en-US" sz="2400" dirty="0"/>
+              <a:t>CREATE TABLE — syntaxe complete</a:t>
+            </a:r>
+            <a:endParaRPr lang="en-US" sz="2100" dirty="0"/>
           </a:p>
         </p:txBody>
       </p:sp>
@@ -2665,7 +2609,7 @@
         </p:nvSpPr>
         <p:spPr>
           <a:xfrm>
-            <a:off x="457200" y="914400"/>
+            <a:off x="457200" y="777240"/>
             <a:ext cx="8229600" cy="409448"/>
           </a:xfrm>
           <a:prstGeom prst="rect">
@@ -2675,13 +2619,6 @@
             <a:srgbClr val="FFFFFF"/>
           </a:solidFill>
           <a:ln/>
-          <a:effectLst>
-            <a:outerShdw sx="100000" sy="100000" kx="0" ky="0" algn="bl" rotWithShape="0" blurRad="50800" dist="25400" dir="8100000">
-              <a:srgbClr val="000000">
-                <a:alpha val="12000"/>
-              </a:srgbClr>
-            </a:outerShdw>
-          </a:effectLst>
         </p:spPr>
       </p:sp>
       <p:sp>
@@ -2692,7 +2629,7 @@
         </p:nvSpPr>
         <p:spPr>
           <a:xfrm>
-            <a:off x="457200" y="914400"/>
+            <a:off x="457200" y="777240"/>
             <a:ext cx="45720" cy="409448"/>
           </a:xfrm>
           <a:prstGeom prst="rect">
@@ -2712,8 +2649,8 @@
         </p:nvSpPr>
         <p:spPr>
           <a:xfrm>
-            <a:off x="685800" y="914400"/>
-            <a:ext cx="7818120" cy="409448"/>
+            <a:off x="640080" y="777240"/>
+            <a:ext cx="7863840" cy="409448"/>
           </a:xfrm>
           <a:prstGeom prst="rect">
             <a:avLst/>
@@ -2751,7 +2688,7 @@
         </p:nvSpPr>
         <p:spPr>
           <a:xfrm>
-            <a:off x="457200" y="1351280"/>
+            <a:off x="457200" y="1214120"/>
             <a:ext cx="8229600" cy="409448"/>
           </a:xfrm>
           <a:prstGeom prst="rect">
@@ -2761,13 +2698,6 @@
             <a:srgbClr val="E3F2FD"/>
           </a:solidFill>
           <a:ln/>
-          <a:effectLst>
-            <a:outerShdw sx="100000" sy="100000" kx="0" ky="0" algn="bl" rotWithShape="0" blurRad="50800" dist="25400" dir="8100000">
-              <a:srgbClr val="000000">
-                <a:alpha val="12000"/>
-              </a:srgbClr>
-            </a:outerShdw>
-          </a:effectLst>
         </p:spPr>
       </p:sp>
       <p:sp>
@@ -2778,7 +2708,7 @@
         </p:nvSpPr>
         <p:spPr>
           <a:xfrm>
-            <a:off x="457200" y="1351280"/>
+            <a:off x="457200" y="1214120"/>
             <a:ext cx="45720" cy="409448"/>
           </a:xfrm>
           <a:prstGeom prst="rect">
@@ -2798,8 +2728,8 @@
         </p:nvSpPr>
         <p:spPr>
           <a:xfrm>
-            <a:off x="685800" y="1351280"/>
-            <a:ext cx="7818120" cy="409448"/>
+            <a:off x="640080" y="1214120"/>
+            <a:ext cx="7863840" cy="409448"/>
           </a:xfrm>
           <a:prstGeom prst="rect">
             <a:avLst/>
@@ -2815,7 +2745,7 @@
               <a:buNone/>
             </a:pPr>
             <a:r>
-              <a:rPr lang="en-US" sz="1200" dirty="0">
+              <a:rPr lang="en-US" sz="1100" dirty="0">
                 <a:solidFill>
                   <a:srgbClr val="1A1A2E"/>
                 </a:solidFill>
@@ -2825,7 +2755,7 @@
               </a:rPr>
               <a:t>  id_artiste INT AUTO_INCREMENT PRIMARY KEY,</a:t>
             </a:r>
-            <a:endParaRPr lang="en-US" sz="1200" dirty="0"/>
+            <a:endParaRPr lang="en-US" sz="1100" dirty="0"/>
           </a:p>
         </p:txBody>
       </p:sp>
@@ -2837,7 +2767,7 @@
         </p:nvSpPr>
         <p:spPr>
           <a:xfrm>
-            <a:off x="457200" y="1788160"/>
+            <a:off x="457200" y="1651000"/>
             <a:ext cx="8229600" cy="409448"/>
           </a:xfrm>
           <a:prstGeom prst="rect">
@@ -2847,13 +2777,6 @@
             <a:srgbClr val="FFFFFF"/>
           </a:solidFill>
           <a:ln/>
-          <a:effectLst>
-            <a:outerShdw sx="100000" sy="100000" kx="0" ky="0" algn="bl" rotWithShape="0" blurRad="50800" dist="25400" dir="8100000">
-              <a:srgbClr val="000000">
-                <a:alpha val="12000"/>
-              </a:srgbClr>
-            </a:outerShdw>
-          </a:effectLst>
         </p:spPr>
       </p:sp>
       <p:sp>
@@ -2864,7 +2787,7 @@
         </p:nvSpPr>
         <p:spPr>
           <a:xfrm>
-            <a:off x="457200" y="1788160"/>
+            <a:off x="457200" y="1651000"/>
             <a:ext cx="45720" cy="409448"/>
           </a:xfrm>
           <a:prstGeom prst="rect">
@@ -2884,8 +2807,8 @@
         </p:nvSpPr>
         <p:spPr>
           <a:xfrm>
-            <a:off x="685800" y="1788160"/>
-            <a:ext cx="7818120" cy="409448"/>
+            <a:off x="640080" y="1651000"/>
+            <a:ext cx="7863840" cy="409448"/>
           </a:xfrm>
           <a:prstGeom prst="rect">
             <a:avLst/>
@@ -2901,7 +2824,7 @@
               <a:buNone/>
             </a:pPr>
             <a:r>
-              <a:rPr lang="en-US" sz="1200" dirty="0">
+              <a:rPr lang="en-US" sz="1100" dirty="0">
                 <a:solidFill>
                   <a:srgbClr val="1A1A2E"/>
                 </a:solidFill>
@@ -2911,7 +2834,7 @@
               </a:rPr>
               <a:t>  nom VARCHAR(100) NOT NULL,</a:t>
             </a:r>
-            <a:endParaRPr lang="en-US" sz="1200" dirty="0"/>
+            <a:endParaRPr lang="en-US" sz="1100" dirty="0"/>
           </a:p>
         </p:txBody>
       </p:sp>
@@ -2923,7 +2846,7 @@
         </p:nvSpPr>
         <p:spPr>
           <a:xfrm>
-            <a:off x="457200" y="2225040"/>
+            <a:off x="457200" y="2087880"/>
             <a:ext cx="8229600" cy="409448"/>
           </a:xfrm>
           <a:prstGeom prst="rect">
@@ -2933,13 +2856,6 @@
             <a:srgbClr val="E3F2FD"/>
           </a:solidFill>
           <a:ln/>
-          <a:effectLst>
-            <a:outerShdw sx="100000" sy="100000" kx="0" ky="0" algn="bl" rotWithShape="0" blurRad="50800" dist="25400" dir="8100000">
-              <a:srgbClr val="000000">
-                <a:alpha val="12000"/>
-              </a:srgbClr>
-            </a:outerShdw>
-          </a:effectLst>
         </p:spPr>
       </p:sp>
       <p:sp>
@@ -2950,7 +2866,7 @@
         </p:nvSpPr>
         <p:spPr>
           <a:xfrm>
-            <a:off x="457200" y="2225040"/>
+            <a:off x="457200" y="2087880"/>
             <a:ext cx="45720" cy="409448"/>
           </a:xfrm>
           <a:prstGeom prst="rect">
@@ -2970,8 +2886,8 @@
         </p:nvSpPr>
         <p:spPr>
           <a:xfrm>
-            <a:off x="685800" y="2225040"/>
-            <a:ext cx="7818120" cy="409448"/>
+            <a:off x="640080" y="2087880"/>
+            <a:ext cx="7863840" cy="409448"/>
           </a:xfrm>
           <a:prstGeom prst="rect">
             <a:avLst/>
@@ -2987,7 +2903,7 @@
               <a:buNone/>
             </a:pPr>
             <a:r>
-              <a:rPr lang="en-US" sz="1200" dirty="0">
+              <a:rPr lang="en-US" sz="1100" dirty="0">
                 <a:solidFill>
                   <a:srgbClr val="1A1A2E"/>
                 </a:solidFill>
@@ -2997,7 +2913,7 @@
               </a:rPr>
               <a:t>  prenom VARCHAR(100) DEFAULT NULL,</a:t>
             </a:r>
-            <a:endParaRPr lang="en-US" sz="1200" dirty="0"/>
+            <a:endParaRPr lang="en-US" sz="1100" dirty="0"/>
           </a:p>
         </p:txBody>
       </p:sp>
@@ -3009,7 +2925,7 @@
         </p:nvSpPr>
         <p:spPr>
           <a:xfrm>
-            <a:off x="457200" y="2661920"/>
+            <a:off x="457200" y="2524760"/>
             <a:ext cx="8229600" cy="409448"/>
           </a:xfrm>
           <a:prstGeom prst="rect">
@@ -3019,13 +2935,6 @@
             <a:srgbClr val="FFFFFF"/>
           </a:solidFill>
           <a:ln/>
-          <a:effectLst>
-            <a:outerShdw sx="100000" sy="100000" kx="0" ky="0" algn="bl" rotWithShape="0" blurRad="50800" dist="25400" dir="8100000">
-              <a:srgbClr val="000000">
-                <a:alpha val="12000"/>
-              </a:srgbClr>
-            </a:outerShdw>
-          </a:effectLst>
         </p:spPr>
       </p:sp>
       <p:sp>
@@ -3036,7 +2945,7 @@
         </p:nvSpPr>
         <p:spPr>
           <a:xfrm>
-            <a:off x="457200" y="2661920"/>
+            <a:off x="457200" y="2524760"/>
             <a:ext cx="45720" cy="409448"/>
           </a:xfrm>
           <a:prstGeom prst="rect">
@@ -3056,8 +2965,8 @@
         </p:nvSpPr>
         <p:spPr>
           <a:xfrm>
-            <a:off x="685800" y="2661920"/>
-            <a:ext cx="7818120" cy="409448"/>
+            <a:off x="640080" y="2524760"/>
+            <a:ext cx="7863840" cy="409448"/>
           </a:xfrm>
           <a:prstGeom prst="rect">
             <a:avLst/>
@@ -3073,7 +2982,7 @@
               <a:buNone/>
             </a:pPr>
             <a:r>
-              <a:rPr lang="en-US" sz="1200" dirty="0">
+              <a:rPr lang="en-US" sz="1100" dirty="0">
                 <a:solidFill>
                   <a:srgbClr val="1A1A2E"/>
                 </a:solidFill>
@@ -3083,7 +2992,7 @@
               </a:rPr>
               <a:t>  email VARCHAR(150) NOT NULL UNIQUE,</a:t>
             </a:r>
-            <a:endParaRPr lang="en-US" sz="1200" dirty="0"/>
+            <a:endParaRPr lang="en-US" sz="1100" dirty="0"/>
           </a:p>
         </p:txBody>
       </p:sp>
@@ -3095,7 +3004,7 @@
         </p:nvSpPr>
         <p:spPr>
           <a:xfrm>
-            <a:off x="457200" y="3098800"/>
+            <a:off x="457200" y="2961640"/>
             <a:ext cx="8229600" cy="409448"/>
           </a:xfrm>
           <a:prstGeom prst="rect">
@@ -3105,13 +3014,6 @@
             <a:srgbClr val="E3F2FD"/>
           </a:solidFill>
           <a:ln/>
-          <a:effectLst>
-            <a:outerShdw sx="100000" sy="100000" kx="0" ky="0" algn="bl" rotWithShape="0" blurRad="50800" dist="25400" dir="8100000">
-              <a:srgbClr val="000000">
-                <a:alpha val="12000"/>
-              </a:srgbClr>
-            </a:outerShdw>
-          </a:effectLst>
         </p:spPr>
       </p:sp>
       <p:sp>
@@ -3122,7 +3024,7 @@
         </p:nvSpPr>
         <p:spPr>
           <a:xfrm>
-            <a:off x="457200" y="3098800"/>
+            <a:off x="457200" y="2961640"/>
             <a:ext cx="45720" cy="409448"/>
           </a:xfrm>
           <a:prstGeom prst="rect">
@@ -3142,8 +3044,8 @@
         </p:nvSpPr>
         <p:spPr>
           <a:xfrm>
-            <a:off x="685800" y="3098800"/>
-            <a:ext cx="7818120" cy="409448"/>
+            <a:off x="640080" y="2961640"/>
+            <a:ext cx="7863840" cy="409448"/>
           </a:xfrm>
           <a:prstGeom prst="rect">
             <a:avLst/>
@@ -3159,7 +3061,7 @@
               <a:buNone/>
             </a:pPr>
             <a:r>
-              <a:rPr lang="en-US" sz="1200" dirty="0">
+              <a:rPr lang="en-US" sz="1100" dirty="0">
                 <a:solidFill>
                   <a:srgbClr val="1A1A2E"/>
                 </a:solidFill>
@@ -3169,7 +3071,7 @@
               </a:rPr>
               <a:t>  telephone VARCHAR(20) DEFAULT NULL,</a:t>
             </a:r>
-            <a:endParaRPr lang="en-US" sz="1200" dirty="0"/>
+            <a:endParaRPr lang="en-US" sz="1100" dirty="0"/>
           </a:p>
         </p:txBody>
       </p:sp>
@@ -3181,7 +3083,7 @@
         </p:nvSpPr>
         <p:spPr>
           <a:xfrm>
-            <a:off x="457200" y="3535680"/>
+            <a:off x="457200" y="3398520"/>
             <a:ext cx="8229600" cy="409448"/>
           </a:xfrm>
           <a:prstGeom prst="rect">
@@ -3191,13 +3093,6 @@
             <a:srgbClr val="FFFFFF"/>
           </a:solidFill>
           <a:ln/>
-          <a:effectLst>
-            <a:outerShdw sx="100000" sy="100000" kx="0" ky="0" algn="bl" rotWithShape="0" blurRad="50800" dist="25400" dir="8100000">
-              <a:srgbClr val="000000">
-                <a:alpha val="12000"/>
-              </a:srgbClr>
-            </a:outerShdw>
-          </a:effectLst>
         </p:spPr>
       </p:sp>
       <p:sp>
@@ -3208,7 +3103,7 @@
         </p:nvSpPr>
         <p:spPr>
           <a:xfrm>
-            <a:off x="457200" y="3535680"/>
+            <a:off x="457200" y="3398520"/>
             <a:ext cx="45720" cy="409448"/>
           </a:xfrm>
           <a:prstGeom prst="rect">
@@ -3228,8 +3123,8 @@
         </p:nvSpPr>
         <p:spPr>
           <a:xfrm>
-            <a:off x="685800" y="3535680"/>
-            <a:ext cx="7818120" cy="409448"/>
+            <a:off x="640080" y="3398520"/>
+            <a:ext cx="7863840" cy="409448"/>
           </a:xfrm>
           <a:prstGeom prst="rect">
             <a:avLst/>
@@ -3245,7 +3140,7 @@
               <a:buNone/>
             </a:pPr>
             <a:r>
-              <a:rPr lang="en-US" sz="1200" dirty="0">
+              <a:rPr lang="en-US" sz="1100" dirty="0">
                 <a:solidFill>
                   <a:srgbClr val="1A1A2E"/>
                 </a:solidFill>
@@ -3255,7 +3150,7 @@
               </a:rPr>
               <a:t>  date_inscription DATE NOT NULL DEFAULT (CURDATE()),</a:t>
             </a:r>
-            <a:endParaRPr lang="en-US" sz="1200" dirty="0"/>
+            <a:endParaRPr lang="en-US" sz="1100" dirty="0"/>
           </a:p>
         </p:txBody>
       </p:sp>
@@ -3267,7 +3162,7 @@
         </p:nvSpPr>
         <p:spPr>
           <a:xfrm>
-            <a:off x="457200" y="3972560"/>
+            <a:off x="457200" y="3835400"/>
             <a:ext cx="8229600" cy="409448"/>
           </a:xfrm>
           <a:prstGeom prst="rect">
@@ -3277,13 +3172,6 @@
             <a:srgbClr val="E3F2FD"/>
           </a:solidFill>
           <a:ln/>
-          <a:effectLst>
-            <a:outerShdw sx="100000" sy="100000" kx="0" ky="0" algn="bl" rotWithShape="0" blurRad="50800" dist="25400" dir="8100000">
-              <a:srgbClr val="000000">
-                <a:alpha val="12000"/>
-              </a:srgbClr>
-            </a:outerShdw>
-          </a:effectLst>
         </p:spPr>
       </p:sp>
       <p:sp>
@@ -3294,7 +3182,7 @@
         </p:nvSpPr>
         <p:spPr>
           <a:xfrm>
-            <a:off x="457200" y="3972560"/>
+            <a:off x="457200" y="3835400"/>
             <a:ext cx="45720" cy="409448"/>
           </a:xfrm>
           <a:prstGeom prst="rect">
@@ -3314,8 +3202,8 @@
         </p:nvSpPr>
         <p:spPr>
           <a:xfrm>
-            <a:off x="685800" y="3972560"/>
-            <a:ext cx="7818120" cy="409448"/>
+            <a:off x="640080" y="3835400"/>
+            <a:ext cx="7863840" cy="409448"/>
           </a:xfrm>
           <a:prstGeom prst="rect">
             <a:avLst/>
@@ -3331,7 +3219,7 @@
               <a:buNone/>
             </a:pPr>
             <a:r>
-              <a:rPr lang="en-US" sz="1200" dirty="0">
+              <a:rPr lang="en-US" sz="1100" dirty="0">
                 <a:solidFill>
                   <a:srgbClr val="1A1A2E"/>
                 </a:solidFill>
@@ -3341,7 +3229,7 @@
               </a:rPr>
               <a:t>  actif BOOLEAN NOT NULL DEFAULT TRUE</a:t>
             </a:r>
-            <a:endParaRPr lang="en-US" sz="1200" dirty="0"/>
+            <a:endParaRPr lang="en-US" sz="1100" dirty="0"/>
           </a:p>
         </p:txBody>
       </p:sp>
@@ -3353,7 +3241,7 @@
         </p:nvSpPr>
         <p:spPr>
           <a:xfrm>
-            <a:off x="457200" y="4409440"/>
+            <a:off x="457200" y="4272280"/>
             <a:ext cx="8229600" cy="409448"/>
           </a:xfrm>
           <a:prstGeom prst="rect">
@@ -3363,13 +3251,6 @@
             <a:srgbClr val="FFFFFF"/>
           </a:solidFill>
           <a:ln/>
-          <a:effectLst>
-            <a:outerShdw sx="100000" sy="100000" kx="0" ky="0" algn="bl" rotWithShape="0" blurRad="50800" dist="25400" dir="8100000">
-              <a:srgbClr val="000000">
-                <a:alpha val="12000"/>
-              </a:srgbClr>
-            </a:outerShdw>
-          </a:effectLst>
         </p:spPr>
       </p:sp>
       <p:sp>
@@ -3380,7 +3261,7 @@
         </p:nvSpPr>
         <p:spPr>
           <a:xfrm>
-            <a:off x="457200" y="4409440"/>
+            <a:off x="457200" y="4272280"/>
             <a:ext cx="45720" cy="409448"/>
           </a:xfrm>
           <a:prstGeom prst="rect">
@@ -3400,8 +3281,8 @@
         </p:nvSpPr>
         <p:spPr>
           <a:xfrm>
-            <a:off x="685800" y="4409440"/>
-            <a:ext cx="7818120" cy="409448"/>
+            <a:off x="640080" y="4272280"/>
+            <a:ext cx="7863840" cy="409448"/>
           </a:xfrm>
           <a:prstGeom prst="rect">
             <a:avLst/>
@@ -3417,7 +3298,7 @@
               <a:buNone/>
             </a:pPr>
             <a:r>
-              <a:rPr lang="en-US" sz="1200" dirty="0">
+              <a:rPr lang="en-US" sz="1100" dirty="0">
                 <a:solidFill>
                   <a:srgbClr val="1A1A2E"/>
                 </a:solidFill>
@@ -3425,9 +3306,9 @@
                 <a:ea typeface="Calibri" pitchFamily="34" charset="-122"/>
                 <a:cs typeface="Calibri" pitchFamily="34" charset="-120"/>
               </a:rPr>
-              <a:t>) COMMENT = 'Artistes SwissSound';</a:t>
-            </a:r>
-            <a:endParaRPr lang="en-US" sz="1200" dirty="0"/>
+              <a:t>  ) COMMENT = 'Artistes SwissSound';</a:t>
+            </a:r>
+            <a:endParaRPr lang="en-US" sz="1100" dirty="0"/>
           </a:p>
         </p:txBody>
       </p:sp>
@@ -3492,7 +3373,7 @@
         <p:spPr>
           <a:xfrm>
             <a:off x="457200" y="182880"/>
-            <a:ext cx="8229600" cy="594360"/>
+            <a:ext cx="8229600" cy="502920"/>
           </a:xfrm>
           <a:prstGeom prst="rect">
             <a:avLst/>
@@ -3508,7 +3389,7 @@
               <a:buNone/>
             </a:pPr>
             <a:r>
-              <a:rPr lang="en-US" sz="2400" b="1" dirty="0">
+              <a:rPr lang="en-US" sz="2100" b="1" dirty="0">
                 <a:solidFill>
                   <a:srgbClr val="0D47A1"/>
                 </a:solidFill>
@@ -3516,9 +3397,9 @@
                 <a:ea typeface="Trebuchet MS" pitchFamily="34" charset="-122"/>
                 <a:cs typeface="Trebuchet MS" pitchFamily="34" charset="-120"/>
               </a:rPr>
-              <a:t>Clés étrangères dans CREATE TABLE</a:t>
-            </a:r>
-            <a:endParaRPr lang="en-US" sz="2400" dirty="0"/>
+              <a:t>Cles etrangeres dans CREATE TABLE</a:t>
+            </a:r>
+            <a:endParaRPr lang="en-US" sz="2100" dirty="0"/>
           </a:p>
         </p:txBody>
       </p:sp>
@@ -3530,7 +3411,7 @@
         </p:nvSpPr>
         <p:spPr>
           <a:xfrm>
-            <a:off x="457200" y="914400"/>
+            <a:off x="457200" y="777240"/>
             <a:ext cx="8229600" cy="330015"/>
           </a:xfrm>
           <a:prstGeom prst="rect">
@@ -3540,13 +3421,6 @@
             <a:srgbClr val="FFFFFF"/>
           </a:solidFill>
           <a:ln/>
-          <a:effectLst>
-            <a:outerShdw sx="100000" sy="100000" kx="0" ky="0" algn="bl" rotWithShape="0" blurRad="50800" dist="25400" dir="8100000">
-              <a:srgbClr val="000000">
-                <a:alpha val="12000"/>
-              </a:srgbClr>
-            </a:outerShdw>
-          </a:effectLst>
         </p:spPr>
       </p:sp>
       <p:sp>
@@ -3557,7 +3431,7 @@
         </p:nvSpPr>
         <p:spPr>
           <a:xfrm>
-            <a:off x="457200" y="914400"/>
+            <a:off x="457200" y="777240"/>
             <a:ext cx="45720" cy="330015"/>
           </a:xfrm>
           <a:prstGeom prst="rect">
@@ -3577,8 +3451,8 @@
         </p:nvSpPr>
         <p:spPr>
           <a:xfrm>
-            <a:off x="685800" y="914400"/>
-            <a:ext cx="7818120" cy="330015"/>
+            <a:off x="640080" y="777240"/>
+            <a:ext cx="7863840" cy="330015"/>
           </a:xfrm>
           <a:prstGeom prst="rect">
             <a:avLst/>
@@ -3616,7 +3490,7 @@
         </p:nvSpPr>
         <p:spPr>
           <a:xfrm>
-            <a:off x="457200" y="1271847"/>
+            <a:off x="457200" y="1134687"/>
             <a:ext cx="8229600" cy="330015"/>
           </a:xfrm>
           <a:prstGeom prst="rect">
@@ -3626,13 +3500,6 @@
             <a:srgbClr val="E3F2FD"/>
           </a:solidFill>
           <a:ln/>
-          <a:effectLst>
-            <a:outerShdw sx="100000" sy="100000" kx="0" ky="0" algn="bl" rotWithShape="0" blurRad="50800" dist="25400" dir="8100000">
-              <a:srgbClr val="000000">
-                <a:alpha val="12000"/>
-              </a:srgbClr>
-            </a:outerShdw>
-          </a:effectLst>
         </p:spPr>
       </p:sp>
       <p:sp>
@@ -3643,7 +3510,7 @@
         </p:nvSpPr>
         <p:spPr>
           <a:xfrm>
-            <a:off x="457200" y="1271847"/>
+            <a:off x="457200" y="1134687"/>
             <a:ext cx="45720" cy="330015"/>
           </a:xfrm>
           <a:prstGeom prst="rect">
@@ -3663,8 +3530,8 @@
         </p:nvSpPr>
         <p:spPr>
           <a:xfrm>
-            <a:off x="685800" y="1271847"/>
-            <a:ext cx="7818120" cy="330015"/>
+            <a:off x="640080" y="1134687"/>
+            <a:ext cx="7863840" cy="330015"/>
           </a:xfrm>
           <a:prstGeom prst="rect">
             <a:avLst/>
@@ -3680,7 +3547,7 @@
               <a:buNone/>
             </a:pPr>
             <a:r>
-              <a:rPr lang="en-US" sz="1200" dirty="0">
+              <a:rPr lang="en-US" sz="1100" dirty="0">
                 <a:solidFill>
                   <a:srgbClr val="1A1A2E"/>
                 </a:solidFill>
@@ -3690,7 +3557,7 @@
               </a:rPr>
               <a:t>  id_album INT AUTO_INCREMENT PRIMARY KEY,</a:t>
             </a:r>
-            <a:endParaRPr lang="en-US" sz="1200" dirty="0"/>
+            <a:endParaRPr lang="en-US" sz="1100" dirty="0"/>
           </a:p>
         </p:txBody>
       </p:sp>
@@ -3702,7 +3569,7 @@
         </p:nvSpPr>
         <p:spPr>
           <a:xfrm>
-            <a:off x="457200" y="1629295"/>
+            <a:off x="457200" y="1492135"/>
             <a:ext cx="8229600" cy="330015"/>
           </a:xfrm>
           <a:prstGeom prst="rect">
@@ -3712,13 +3579,6 @@
             <a:srgbClr val="FFFFFF"/>
           </a:solidFill>
           <a:ln/>
-          <a:effectLst>
-            <a:outerShdw sx="100000" sy="100000" kx="0" ky="0" algn="bl" rotWithShape="0" blurRad="50800" dist="25400" dir="8100000">
-              <a:srgbClr val="000000">
-                <a:alpha val="12000"/>
-              </a:srgbClr>
-            </a:outerShdw>
-          </a:effectLst>
         </p:spPr>
       </p:sp>
       <p:sp>
@@ -3729,7 +3589,7 @@
         </p:nvSpPr>
         <p:spPr>
           <a:xfrm>
-            <a:off x="457200" y="1629295"/>
+            <a:off x="457200" y="1492135"/>
             <a:ext cx="45720" cy="330015"/>
           </a:xfrm>
           <a:prstGeom prst="rect">
@@ -3749,8 +3609,8 @@
         </p:nvSpPr>
         <p:spPr>
           <a:xfrm>
-            <a:off x="685800" y="1629295"/>
-            <a:ext cx="7818120" cy="330015"/>
+            <a:off x="640080" y="1492135"/>
+            <a:ext cx="7863840" cy="330015"/>
           </a:xfrm>
           <a:prstGeom prst="rect">
             <a:avLst/>
@@ -3766,7 +3626,7 @@
               <a:buNone/>
             </a:pPr>
             <a:r>
-              <a:rPr lang="en-US" sz="1200" dirty="0">
+              <a:rPr lang="en-US" sz="1100" dirty="0">
                 <a:solidFill>
                   <a:srgbClr val="1A1A2E"/>
                 </a:solidFill>
@@ -3776,7 +3636,7 @@
               </a:rPr>
               <a:t>  titre VARCHAR(200) NOT NULL,</a:t>
             </a:r>
-            <a:endParaRPr lang="en-US" sz="1200" dirty="0"/>
+            <a:endParaRPr lang="en-US" sz="1100" dirty="0"/>
           </a:p>
         </p:txBody>
       </p:sp>
@@ -3788,7 +3648,7 @@
         </p:nvSpPr>
         <p:spPr>
           <a:xfrm>
-            <a:off x="457200" y="1986742"/>
+            <a:off x="457200" y="1849582"/>
             <a:ext cx="8229600" cy="330015"/>
           </a:xfrm>
           <a:prstGeom prst="rect">
@@ -3798,13 +3658,6 @@
             <a:srgbClr val="E3F2FD"/>
           </a:solidFill>
           <a:ln/>
-          <a:effectLst>
-            <a:outerShdw sx="100000" sy="100000" kx="0" ky="0" algn="bl" rotWithShape="0" blurRad="50800" dist="25400" dir="8100000">
-              <a:srgbClr val="000000">
-                <a:alpha val="12000"/>
-              </a:srgbClr>
-            </a:outerShdw>
-          </a:effectLst>
         </p:spPr>
       </p:sp>
       <p:sp>
@@ -3815,7 +3668,7 @@
         </p:nvSpPr>
         <p:spPr>
           <a:xfrm>
-            <a:off x="457200" y="1986742"/>
+            <a:off x="457200" y="1849582"/>
             <a:ext cx="45720" cy="330015"/>
           </a:xfrm>
           <a:prstGeom prst="rect">
@@ -3835,8 +3688,8 @@
         </p:nvSpPr>
         <p:spPr>
           <a:xfrm>
-            <a:off x="685800" y="1986742"/>
-            <a:ext cx="7818120" cy="330015"/>
+            <a:off x="640080" y="1849582"/>
+            <a:ext cx="7863840" cy="330015"/>
           </a:xfrm>
           <a:prstGeom prst="rect">
             <a:avLst/>
@@ -3852,7 +3705,7 @@
               <a:buNone/>
             </a:pPr>
             <a:r>
-              <a:rPr lang="en-US" sz="1200" dirty="0">
+              <a:rPr lang="en-US" sz="1100" dirty="0">
                 <a:solidFill>
                   <a:srgbClr val="1A1A2E"/>
                 </a:solidFill>
@@ -3862,7 +3715,7 @@
               </a:rPr>
               <a:t>  prix DECIMAL(8,2) DEFAULT NULL,</a:t>
             </a:r>
-            <a:endParaRPr lang="en-US" sz="1200" dirty="0"/>
+            <a:endParaRPr lang="en-US" sz="1100" dirty="0"/>
           </a:p>
         </p:txBody>
       </p:sp>
@@ -3874,7 +3727,7 @@
         </p:nvSpPr>
         <p:spPr>
           <a:xfrm>
-            <a:off x="457200" y="2344189"/>
+            <a:off x="457200" y="2207029"/>
             <a:ext cx="8229600" cy="330015"/>
           </a:xfrm>
           <a:prstGeom prst="rect">
@@ -3884,13 +3737,6 @@
             <a:srgbClr val="FFFFFF"/>
           </a:solidFill>
           <a:ln/>
-          <a:effectLst>
-            <a:outerShdw sx="100000" sy="100000" kx="0" ky="0" algn="bl" rotWithShape="0" blurRad="50800" dist="25400" dir="8100000">
-              <a:srgbClr val="000000">
-                <a:alpha val="12000"/>
-              </a:srgbClr>
-            </a:outerShdw>
-          </a:effectLst>
         </p:spPr>
       </p:sp>
       <p:sp>
@@ -3901,7 +3747,7 @@
         </p:nvSpPr>
         <p:spPr>
           <a:xfrm>
-            <a:off x="457200" y="2344189"/>
+            <a:off x="457200" y="2207029"/>
             <a:ext cx="45720" cy="330015"/>
           </a:xfrm>
           <a:prstGeom prst="rect">
@@ -3921,8 +3767,8 @@
         </p:nvSpPr>
         <p:spPr>
           <a:xfrm>
-            <a:off x="685800" y="2344189"/>
-            <a:ext cx="7818120" cy="330015"/>
+            <a:off x="640080" y="2207029"/>
+            <a:ext cx="7863840" cy="330015"/>
           </a:xfrm>
           <a:prstGeom prst="rect">
             <a:avLst/>
@@ -3938,7 +3784,7 @@
               <a:buNone/>
             </a:pPr>
             <a:r>
-              <a:rPr lang="en-US" sz="1200" dirty="0">
+              <a:rPr lang="en-US" sz="1100" dirty="0">
                 <a:solidFill>
                   <a:srgbClr val="1A1A2E"/>
                 </a:solidFill>
@@ -3948,7 +3794,7 @@
               </a:rPr>
               <a:t>  id_artiste INT NOT NULL,</a:t>
             </a:r>
-            <a:endParaRPr lang="en-US" sz="1200" dirty="0"/>
+            <a:endParaRPr lang="en-US" sz="1100" dirty="0"/>
           </a:p>
         </p:txBody>
       </p:sp>
@@ -3960,7 +3806,7 @@
         </p:nvSpPr>
         <p:spPr>
           <a:xfrm>
-            <a:off x="457200" y="2701636"/>
+            <a:off x="457200" y="2564476"/>
             <a:ext cx="8229600" cy="330015"/>
           </a:xfrm>
           <a:prstGeom prst="rect">
@@ -3970,13 +3816,6 @@
             <a:srgbClr val="E3F2FD"/>
           </a:solidFill>
           <a:ln/>
-          <a:effectLst>
-            <a:outerShdw sx="100000" sy="100000" kx="0" ky="0" algn="bl" rotWithShape="0" blurRad="50800" dist="25400" dir="8100000">
-              <a:srgbClr val="000000">
-                <a:alpha val="12000"/>
-              </a:srgbClr>
-            </a:outerShdw>
-          </a:effectLst>
         </p:spPr>
       </p:sp>
       <p:sp>
@@ -3987,7 +3826,7 @@
         </p:nvSpPr>
         <p:spPr>
           <a:xfrm>
-            <a:off x="457200" y="2701636"/>
+            <a:off x="457200" y="2564476"/>
             <a:ext cx="45720" cy="330015"/>
           </a:xfrm>
           <a:prstGeom prst="rect">
@@ -4007,8 +3846,8 @@
         </p:nvSpPr>
         <p:spPr>
           <a:xfrm>
-            <a:off x="685800" y="2701636"/>
-            <a:ext cx="7818120" cy="330015"/>
+            <a:off x="640080" y="2564476"/>
+            <a:ext cx="7863840" cy="330015"/>
           </a:xfrm>
           <a:prstGeom prst="rect">
             <a:avLst/>
@@ -4046,7 +3885,7 @@
         </p:nvSpPr>
         <p:spPr>
           <a:xfrm>
-            <a:off x="457200" y="3059084"/>
+            <a:off x="457200" y="2921924"/>
             <a:ext cx="8229600" cy="330015"/>
           </a:xfrm>
           <a:prstGeom prst="rect">
@@ -4056,13 +3895,6 @@
             <a:srgbClr val="FFFFFF"/>
           </a:solidFill>
           <a:ln/>
-          <a:effectLst>
-            <a:outerShdw sx="100000" sy="100000" kx="0" ky="0" algn="bl" rotWithShape="0" blurRad="50800" dist="25400" dir="8100000">
-              <a:srgbClr val="000000">
-                <a:alpha val="12000"/>
-              </a:srgbClr>
-            </a:outerShdw>
-          </a:effectLst>
         </p:spPr>
       </p:sp>
       <p:sp>
@@ -4073,7 +3905,7 @@
         </p:nvSpPr>
         <p:spPr>
           <a:xfrm>
-            <a:off x="457200" y="3059084"/>
+            <a:off x="457200" y="2921924"/>
             <a:ext cx="45720" cy="330015"/>
           </a:xfrm>
           <a:prstGeom prst="rect">
@@ -4093,8 +3925,8 @@
         </p:nvSpPr>
         <p:spPr>
           <a:xfrm>
-            <a:off x="685800" y="3059084"/>
-            <a:ext cx="7818120" cy="330015"/>
+            <a:off x="640080" y="2921924"/>
+            <a:ext cx="7863840" cy="330015"/>
           </a:xfrm>
           <a:prstGeom prst="rect">
             <a:avLst/>
@@ -4132,7 +3964,7 @@
         </p:nvSpPr>
         <p:spPr>
           <a:xfrm>
-            <a:off x="457200" y="3416531"/>
+            <a:off x="457200" y="3279371"/>
             <a:ext cx="8229600" cy="330015"/>
           </a:xfrm>
           <a:prstGeom prst="rect">
@@ -4142,13 +3974,6 @@
             <a:srgbClr val="E3F2FD"/>
           </a:solidFill>
           <a:ln/>
-          <a:effectLst>
-            <a:outerShdw sx="100000" sy="100000" kx="0" ky="0" algn="bl" rotWithShape="0" blurRad="50800" dist="25400" dir="8100000">
-              <a:srgbClr val="000000">
-                <a:alpha val="12000"/>
-              </a:srgbClr>
-            </a:outerShdw>
-          </a:effectLst>
         </p:spPr>
       </p:sp>
       <p:sp>
@@ -4159,7 +3984,7 @@
         </p:nvSpPr>
         <p:spPr>
           <a:xfrm>
-            <a:off x="457200" y="3416531"/>
+            <a:off x="457200" y="3279371"/>
             <a:ext cx="45720" cy="330015"/>
           </a:xfrm>
           <a:prstGeom prst="rect">
@@ -4179,8 +4004,8 @@
         </p:nvSpPr>
         <p:spPr>
           <a:xfrm>
-            <a:off x="685800" y="3416531"/>
-            <a:ext cx="7818120" cy="330015"/>
+            <a:off x="640080" y="3279371"/>
+            <a:ext cx="7863840" cy="330015"/>
           </a:xfrm>
           <a:prstGeom prst="rect">
             <a:avLst/>
@@ -4196,7 +4021,7 @@
               <a:buNone/>
             </a:pPr>
             <a:r>
-              <a:rPr lang="en-US" sz="1200" dirty="0">
+              <a:rPr lang="en-US" sz="1100" dirty="0">
                 <a:solidFill>
                   <a:srgbClr val="1A1A2E"/>
                 </a:solidFill>
@@ -4206,7 +4031,7 @@
               </a:rPr>
               <a:t>    REFERENCES artiste(id_artiste)</a:t>
             </a:r>
-            <a:endParaRPr lang="en-US" sz="1200" dirty="0"/>
+            <a:endParaRPr lang="en-US" sz="1100" dirty="0"/>
           </a:p>
         </p:txBody>
       </p:sp>
@@ -4218,7 +4043,7 @@
         </p:nvSpPr>
         <p:spPr>
           <a:xfrm>
-            <a:off x="457200" y="3773978"/>
+            <a:off x="457200" y="3636818"/>
             <a:ext cx="8229600" cy="330015"/>
           </a:xfrm>
           <a:prstGeom prst="rect">
@@ -4228,13 +4053,6 @@
             <a:srgbClr val="FFFFFF"/>
           </a:solidFill>
           <a:ln/>
-          <a:effectLst>
-            <a:outerShdw sx="100000" sy="100000" kx="0" ky="0" algn="bl" rotWithShape="0" blurRad="50800" dist="25400" dir="8100000">
-              <a:srgbClr val="000000">
-                <a:alpha val="12000"/>
-              </a:srgbClr>
-            </a:outerShdw>
-          </a:effectLst>
         </p:spPr>
       </p:sp>
       <p:sp>
@@ -4245,7 +4063,7 @@
         </p:nvSpPr>
         <p:spPr>
           <a:xfrm>
-            <a:off x="457200" y="3773978"/>
+            <a:off x="457200" y="3636818"/>
             <a:ext cx="45720" cy="330015"/>
           </a:xfrm>
           <a:prstGeom prst="rect">
@@ -4265,8 +4083,8 @@
         </p:nvSpPr>
         <p:spPr>
           <a:xfrm>
-            <a:off x="685800" y="3773978"/>
-            <a:ext cx="7818120" cy="330015"/>
+            <a:off x="640080" y="3636818"/>
+            <a:ext cx="7863840" cy="330015"/>
           </a:xfrm>
           <a:prstGeom prst="rect">
             <a:avLst/>
@@ -4290,7 +4108,7 @@
                 <a:ea typeface="JetBrains Mono" pitchFamily="34" charset="-122"/>
                 <a:cs typeface="JetBrains Mono" pitchFamily="34" charset="-120"/>
               </a:rPr>
-              <a:t>    ON DELETE RESTRICT ON UPDATE CASCADE,</a:t>
+              <a:t>    ON DELETE RESTRICT ON UPDATE CASCADE</a:t>
             </a:r>
             <a:endParaRPr lang="en-US" sz="1000" dirty="0"/>
           </a:p>
@@ -4304,7 +4122,7 @@
         </p:nvSpPr>
         <p:spPr>
           <a:xfrm>
-            <a:off x="457200" y="4131425"/>
+            <a:off x="457200" y="3994265"/>
             <a:ext cx="8229600" cy="330015"/>
           </a:xfrm>
           <a:prstGeom prst="rect">
@@ -4314,13 +4132,6 @@
             <a:srgbClr val="E3F2FD"/>
           </a:solidFill>
           <a:ln/>
-          <a:effectLst>
-            <a:outerShdw sx="100000" sy="100000" kx="0" ky="0" algn="bl" rotWithShape="0" blurRad="50800" dist="25400" dir="8100000">
-              <a:srgbClr val="000000">
-                <a:alpha val="12000"/>
-              </a:srgbClr>
-            </a:outerShdw>
-          </a:effectLst>
         </p:spPr>
       </p:sp>
       <p:sp>
@@ -4331,7 +4142,7 @@
         </p:nvSpPr>
         <p:spPr>
           <a:xfrm>
-            <a:off x="457200" y="4131425"/>
+            <a:off x="457200" y="3994265"/>
             <a:ext cx="45720" cy="330015"/>
           </a:xfrm>
           <a:prstGeom prst="rect">
@@ -4351,8 +4162,8 @@
         </p:nvSpPr>
         <p:spPr>
           <a:xfrm>
-            <a:off x="685800" y="4131425"/>
-            <a:ext cx="7818120" cy="330015"/>
+            <a:off x="640080" y="3994265"/>
+            <a:ext cx="7863840" cy="330015"/>
           </a:xfrm>
           <a:prstGeom prst="rect">
             <a:avLst/>
@@ -4368,93 +4179,7 @@
               <a:buNone/>
             </a:pPr>
             <a:r>
-              <a:rPr lang="en-US" sz="1000" dirty="0">
-                <a:solidFill>
-                  <a:srgbClr val="0D47A1"/>
-                </a:solidFill>
-                <a:latin typeface="JetBrains Mono" pitchFamily="34" charset="0"/>
-                <a:ea typeface="JetBrains Mono" pitchFamily="34" charset="-122"/>
-                <a:cs typeface="JetBrains Mono" pitchFamily="34" charset="-120"/>
-              </a:rPr>
-              <a:t>  CONSTRAINT chk_prix CHECK (prix IS NULL OR prix &gt;= 0)</a:t>
-            </a:r>
-            <a:endParaRPr lang="en-US" sz="1000" dirty="0"/>
-          </a:p>
-        </p:txBody>
-      </p:sp>
-      <p:sp>
-        <p:nvSpPr>
-          <p:cNvPr id="34" name="Shape 32"/>
-          <p:cNvSpPr/>
-          <p:nvPr/>
-        </p:nvSpPr>
-        <p:spPr>
-          <a:xfrm>
-            <a:off x="457200" y="4488873"/>
-            <a:ext cx="8229600" cy="330015"/>
-          </a:xfrm>
-          <a:prstGeom prst="rect">
-            <a:avLst/>
-          </a:prstGeom>
-          <a:solidFill>
-            <a:srgbClr val="FFFFFF"/>
-          </a:solidFill>
-          <a:ln/>
-          <a:effectLst>
-            <a:outerShdw sx="100000" sy="100000" kx="0" ky="0" algn="bl" rotWithShape="0" blurRad="50800" dist="25400" dir="8100000">
-              <a:srgbClr val="000000">
-                <a:alpha val="12000"/>
-              </a:srgbClr>
-            </a:outerShdw>
-          </a:effectLst>
-        </p:spPr>
-      </p:sp>
-      <p:sp>
-        <p:nvSpPr>
-          <p:cNvPr id="35" name="Shape 33"/>
-          <p:cNvSpPr/>
-          <p:nvPr/>
-        </p:nvSpPr>
-        <p:spPr>
-          <a:xfrm>
-            <a:off x="457200" y="4488873"/>
-            <a:ext cx="45720" cy="330015"/>
-          </a:xfrm>
-          <a:prstGeom prst="rect">
-            <a:avLst/>
-          </a:prstGeom>
-          <a:solidFill>
-            <a:srgbClr val="1565C0"/>
-          </a:solidFill>
-          <a:ln/>
-        </p:spPr>
-      </p:sp>
-      <p:sp>
-        <p:nvSpPr>
-          <p:cNvPr id="36" name="Text 34"/>
-          <p:cNvSpPr/>
-          <p:nvPr/>
-        </p:nvSpPr>
-        <p:spPr>
-          <a:xfrm>
-            <a:off x="685800" y="4488873"/>
-            <a:ext cx="7818120" cy="330015"/>
-          </a:xfrm>
-          <a:prstGeom prst="rect">
-            <a:avLst/>
-          </a:prstGeom>
-          <a:noFill/>
-          <a:ln/>
-        </p:spPr>
-        <p:txBody>
-          <a:bodyPr wrap="square" lIns="0" tIns="0" rIns="0" bIns="0" rtlCol="0" anchor="ctr"/>
-          <a:lstStyle/>
-          <a:p>
-            <a:pPr indent="0" marL="0">
-              <a:buNone/>
-            </a:pPr>
-            <a:r>
-              <a:rPr lang="en-US" sz="1200" dirty="0">
+              <a:rPr lang="en-US" sz="1100" dirty="0">
                 <a:solidFill>
                   <a:srgbClr val="1A1A2E"/>
                 </a:solidFill>
@@ -4462,9 +4187,88 @@
                 <a:ea typeface="Calibri" pitchFamily="34" charset="-122"/>
                 <a:cs typeface="Calibri" pitchFamily="34" charset="-120"/>
               </a:rPr>
-              <a:t>);</a:t>
-            </a:r>
-            <a:endParaRPr lang="en-US" sz="1200" dirty="0"/>
+              <a:t>  );</a:t>
+            </a:r>
+            <a:endParaRPr lang="en-US" sz="1100" dirty="0"/>
+          </a:p>
+        </p:txBody>
+      </p:sp>
+      <p:sp>
+        <p:nvSpPr>
+          <p:cNvPr id="34" name="Shape 32"/>
+          <p:cNvSpPr/>
+          <p:nvPr/>
+        </p:nvSpPr>
+        <p:spPr>
+          <a:xfrm>
+            <a:off x="457200" y="4351713"/>
+            <a:ext cx="8229600" cy="330015"/>
+          </a:xfrm>
+          <a:prstGeom prst="rect">
+            <a:avLst/>
+          </a:prstGeom>
+          <a:solidFill>
+            <a:srgbClr val="FFFFFF"/>
+          </a:solidFill>
+          <a:ln/>
+        </p:spPr>
+      </p:sp>
+      <p:sp>
+        <p:nvSpPr>
+          <p:cNvPr id="35" name="Shape 33"/>
+          <p:cNvSpPr/>
+          <p:nvPr/>
+        </p:nvSpPr>
+        <p:spPr>
+          <a:xfrm>
+            <a:off x="457200" y="4351713"/>
+            <a:ext cx="45720" cy="330015"/>
+          </a:xfrm>
+          <a:prstGeom prst="rect">
+            <a:avLst/>
+          </a:prstGeom>
+          <a:solidFill>
+            <a:srgbClr val="1565C0"/>
+          </a:solidFill>
+          <a:ln/>
+        </p:spPr>
+      </p:sp>
+      <p:sp>
+        <p:nvSpPr>
+          <p:cNvPr id="36" name="Text 34"/>
+          <p:cNvSpPr/>
+          <p:nvPr/>
+        </p:nvSpPr>
+        <p:spPr>
+          <a:xfrm>
+            <a:off x="640080" y="4351713"/>
+            <a:ext cx="7863840" cy="330015"/>
+          </a:xfrm>
+          <a:prstGeom prst="rect">
+            <a:avLst/>
+          </a:prstGeom>
+          <a:noFill/>
+          <a:ln/>
+        </p:spPr>
+        <p:txBody>
+          <a:bodyPr wrap="square" lIns="0" tIns="0" rIns="0" bIns="0" rtlCol="0" anchor="ctr"/>
+          <a:lstStyle/>
+          <a:p>
+            <a:pPr indent="0" marL="0">
+              <a:buNone/>
+            </a:pPr>
+            <a:r>
+              <a:rPr lang="en-US" sz="1100" dirty="0">
+                <a:solidFill>
+                  <a:srgbClr val="1A1A2E"/>
+                </a:solidFill>
+                <a:latin typeface="Calibri" pitchFamily="34" charset="0"/>
+                <a:ea typeface="Calibri" pitchFamily="34" charset="-122"/>
+                <a:cs typeface="Calibri" pitchFamily="34" charset="-120"/>
+              </a:rPr>
+              <a:t>RESTRICT = on ne peut pas supprimer un artiste qui a des albums</a:t>
+            </a:r>
+            <a:endParaRPr lang="en-US" sz="1100" dirty="0"/>
           </a:p>
         </p:txBody>
       </p:sp>
@@ -4529,7 +4333,7 @@
         <p:spPr>
           <a:xfrm>
             <a:off x="457200" y="182880"/>
-            <a:ext cx="8229600" cy="594360"/>
+            <a:ext cx="8229600" cy="502920"/>
           </a:xfrm>
           <a:prstGeom prst="rect">
             <a:avLst/>
@@ -4545,7 +4349,7 @@
               <a:buNone/>
             </a:pPr>
             <a:r>
-              <a:rPr lang="en-US" sz="2400" b="1" dirty="0">
+              <a:rPr lang="en-US" sz="2100" b="1" dirty="0">
                 <a:solidFill>
                   <a:srgbClr val="0D47A1"/>
                 </a:solidFill>
@@ -4553,9 +4357,9 @@
                 <a:ea typeface="Trebuchet MS" pitchFamily="34" charset="-122"/>
                 <a:cs typeface="Trebuchet MS" pitchFamily="34" charset="-120"/>
               </a:rPr>
-              <a:t>Ordre de création (dépendances FK)</a:t>
-            </a:r>
-            <a:endParaRPr lang="en-US" sz="2400" dirty="0"/>
+              <a:t>Ordre de creation (dependances FK)</a:t>
+            </a:r>
+            <a:endParaRPr lang="en-US" sz="2100" dirty="0"/>
           </a:p>
         </p:txBody>
       </p:sp>
@@ -4567,7 +4371,7 @@
         </p:nvSpPr>
         <p:spPr>
           <a:xfrm>
-            <a:off x="457200" y="914400"/>
+            <a:off x="457200" y="777240"/>
             <a:ext cx="8229600" cy="330015"/>
           </a:xfrm>
           <a:prstGeom prst="rect">
@@ -4577,13 +4381,6 @@
             <a:srgbClr val="FFFFFF"/>
           </a:solidFill>
           <a:ln/>
-          <a:effectLst>
-            <a:outerShdw sx="100000" sy="100000" kx="0" ky="0" algn="bl" rotWithShape="0" blurRad="50800" dist="25400" dir="8100000">
-              <a:srgbClr val="000000">
-                <a:alpha val="12000"/>
-              </a:srgbClr>
-            </a:outerShdw>
-          </a:effectLst>
         </p:spPr>
       </p:sp>
       <p:sp>
@@ -4594,7 +4391,7 @@
         </p:nvSpPr>
         <p:spPr>
           <a:xfrm>
-            <a:off x="457200" y="914400"/>
+            <a:off x="457200" y="777240"/>
             <a:ext cx="45720" cy="330015"/>
           </a:xfrm>
           <a:prstGeom prst="rect">
@@ -4614,8 +4411,8 @@
         </p:nvSpPr>
         <p:spPr>
           <a:xfrm>
-            <a:off x="685800" y="914400"/>
-            <a:ext cx="7818120" cy="330015"/>
+            <a:off x="640080" y="777240"/>
+            <a:ext cx="7863840" cy="330015"/>
           </a:xfrm>
           <a:prstGeom prst="rect">
             <a:avLst/>
@@ -4631,7 +4428,7 @@
               <a:buNone/>
             </a:pPr>
             <a:r>
-              <a:rPr lang="en-US" sz="1200" dirty="0">
+              <a:rPr lang="en-US" sz="1100" dirty="0">
                 <a:solidFill>
                   <a:srgbClr val="1A1A2E"/>
                 </a:solidFill>
@@ -4639,9 +4436,9 @@
                 <a:ea typeface="Calibri" pitchFamily="34" charset="-122"/>
                 <a:cs typeface="Calibri" pitchFamily="34" charset="-120"/>
               </a:rPr>
-              <a:t>⚠️ La table RÉFÉRENCÉE doit exister AVANT la table qui la RÉFÉRENCE</a:t>
-            </a:r>
-            <a:endParaRPr lang="en-US" sz="1200" dirty="0"/>
+              <a:t>La table REFERENCEE doit exister AVANT la table qui la REFERENCE</a:t>
+            </a:r>
+            <a:endParaRPr lang="en-US" sz="1100" dirty="0"/>
           </a:p>
         </p:txBody>
       </p:sp>
@@ -4653,7 +4450,7 @@
         </p:nvSpPr>
         <p:spPr>
           <a:xfrm>
-            <a:off x="457200" y="1271847"/>
+            <a:off x="457200" y="1134687"/>
             <a:ext cx="8229600" cy="330015"/>
           </a:xfrm>
           <a:prstGeom prst="rect">
@@ -4663,13 +4460,6 @@
             <a:srgbClr val="E3F2FD"/>
           </a:solidFill>
           <a:ln/>
-          <a:effectLst>
-            <a:outerShdw sx="100000" sy="100000" kx="0" ky="0" algn="bl" rotWithShape="0" blurRad="50800" dist="25400" dir="8100000">
-              <a:srgbClr val="000000">
-                <a:alpha val="12000"/>
-              </a:srgbClr>
-            </a:outerShdw>
-          </a:effectLst>
         </p:spPr>
       </p:sp>
       <p:sp>
@@ -4680,7 +4470,7 @@
         </p:nvSpPr>
         <p:spPr>
           <a:xfrm>
-            <a:off x="457200" y="1271847"/>
+            <a:off x="457200" y="1134687"/>
             <a:ext cx="45720" cy="330015"/>
           </a:xfrm>
           <a:prstGeom prst="rect">
@@ -4700,8 +4490,8 @@
         </p:nvSpPr>
         <p:spPr>
           <a:xfrm>
-            <a:off x="685800" y="1271847"/>
-            <a:ext cx="7818120" cy="330015"/>
+            <a:off x="640080" y="1134687"/>
+            <a:ext cx="7863840" cy="330015"/>
           </a:xfrm>
           <a:prstGeom prst="rect">
             <a:avLst/>
@@ -4717,7 +4507,7 @@
               <a:buNone/>
             </a:pPr>
             <a:r>
-              <a:rPr lang="en-US" sz="1200" dirty="0">
+              <a:rPr lang="en-US" sz="1100" dirty="0">
                 <a:solidFill>
                   <a:srgbClr val="1A1A2E"/>
                 </a:solidFill>
@@ -4727,7 +4517,7 @@
               </a:rPr>
               <a:t>SwissSound — ordre correct :</a:t>
             </a:r>
-            <a:endParaRPr lang="en-US" sz="1200" dirty="0"/>
+            <a:endParaRPr lang="en-US" sz="1100" dirty="0"/>
           </a:p>
         </p:txBody>
       </p:sp>
@@ -4739,7 +4529,7 @@
         </p:nvSpPr>
         <p:spPr>
           <a:xfrm>
-            <a:off x="457200" y="1629295"/>
+            <a:off x="457200" y="1492135"/>
             <a:ext cx="8229600" cy="330015"/>
           </a:xfrm>
           <a:prstGeom prst="rect">
@@ -4749,13 +4539,6 @@
             <a:srgbClr val="FFFFFF"/>
           </a:solidFill>
           <a:ln/>
-          <a:effectLst>
-            <a:outerShdw sx="100000" sy="100000" kx="0" ky="0" algn="bl" rotWithShape="0" blurRad="50800" dist="25400" dir="8100000">
-              <a:srgbClr val="000000">
-                <a:alpha val="12000"/>
-              </a:srgbClr>
-            </a:outerShdw>
-          </a:effectLst>
         </p:spPr>
       </p:sp>
       <p:sp>
@@ -4766,7 +4549,7 @@
         </p:nvSpPr>
         <p:spPr>
           <a:xfrm>
-            <a:off x="457200" y="1629295"/>
+            <a:off x="457200" y="1492135"/>
             <a:ext cx="45720" cy="330015"/>
           </a:xfrm>
           <a:prstGeom prst="rect">
@@ -4786,8 +4569,8 @@
         </p:nvSpPr>
         <p:spPr>
           <a:xfrm>
-            <a:off x="685800" y="1629295"/>
-            <a:ext cx="7818120" cy="330015"/>
+            <a:off x="640080" y="1492135"/>
+            <a:ext cx="7863840" cy="330015"/>
           </a:xfrm>
           <a:prstGeom prst="rect">
             <a:avLst/>
@@ -4803,7 +4586,7 @@
               <a:buNone/>
             </a:pPr>
             <a:r>
-              <a:rPr lang="en-US" sz="1200" dirty="0">
+              <a:rPr lang="en-US" sz="1100" dirty="0">
                 <a:solidFill>
                   <a:srgbClr val="1A1A2E"/>
                 </a:solidFill>
@@ -4811,9 +4594,9 @@
                 <a:ea typeface="Calibri" pitchFamily="34" charset="-122"/>
                 <a:cs typeface="Calibri" pitchFamily="34" charset="-120"/>
               </a:rPr>
-              <a:t>1. genre (aucune FK)</a:t>
-            </a:r>
-            <a:endParaRPr lang="en-US" sz="1200" dirty="0"/>
+              <a:t>  1. genre (aucune FK)</a:t>
+            </a:r>
+            <a:endParaRPr lang="en-US" sz="1100" dirty="0"/>
           </a:p>
         </p:txBody>
       </p:sp>
@@ -4825,7 +4608,7 @@
         </p:nvSpPr>
         <p:spPr>
           <a:xfrm>
-            <a:off x="457200" y="1986742"/>
+            <a:off x="457200" y="1849582"/>
             <a:ext cx="8229600" cy="330015"/>
           </a:xfrm>
           <a:prstGeom prst="rect">
@@ -4835,13 +4618,6 @@
             <a:srgbClr val="E3F2FD"/>
           </a:solidFill>
           <a:ln/>
-          <a:effectLst>
-            <a:outerShdw sx="100000" sy="100000" kx="0" ky="0" algn="bl" rotWithShape="0" blurRad="50800" dist="25400" dir="8100000">
-              <a:srgbClr val="000000">
-                <a:alpha val="12000"/>
-              </a:srgbClr>
-            </a:outerShdw>
-          </a:effectLst>
         </p:spPr>
       </p:sp>
       <p:sp>
@@ -4852,7 +4628,7 @@
         </p:nvSpPr>
         <p:spPr>
           <a:xfrm>
-            <a:off x="457200" y="1986742"/>
+            <a:off x="457200" y="1849582"/>
             <a:ext cx="45720" cy="330015"/>
           </a:xfrm>
           <a:prstGeom prst="rect">
@@ -4872,8 +4648,8 @@
         </p:nvSpPr>
         <p:spPr>
           <a:xfrm>
-            <a:off x="685800" y="1986742"/>
-            <a:ext cx="7818120" cy="330015"/>
+            <a:off x="640080" y="1849582"/>
+            <a:ext cx="7863840" cy="330015"/>
           </a:xfrm>
           <a:prstGeom prst="rect">
             <a:avLst/>
@@ -4889,7 +4665,7 @@
               <a:buNone/>
             </a:pPr>
             <a:r>
-              <a:rPr lang="en-US" sz="1200" dirty="0">
+              <a:rPr lang="en-US" sz="1100" dirty="0">
                 <a:solidFill>
                   <a:srgbClr val="1A1A2E"/>
                 </a:solidFill>
@@ -4897,9 +4673,9 @@
                 <a:ea typeface="Calibri" pitchFamily="34" charset="-122"/>
                 <a:cs typeface="Calibri" pitchFamily="34" charset="-120"/>
               </a:rPr>
-              <a:t>2. artiste (aucune FK)</a:t>
-            </a:r>
-            <a:endParaRPr lang="en-US" sz="1200" dirty="0"/>
+              <a:t>  2. artiste (aucune FK)</a:t>
+            </a:r>
+            <a:endParaRPr lang="en-US" sz="1100" dirty="0"/>
           </a:p>
         </p:txBody>
       </p:sp>
@@ -4911,7 +4687,7 @@
         </p:nvSpPr>
         <p:spPr>
           <a:xfrm>
-            <a:off x="457200" y="2344189"/>
+            <a:off x="457200" y="2207029"/>
             <a:ext cx="8229600" cy="330015"/>
           </a:xfrm>
           <a:prstGeom prst="rect">
@@ -4921,13 +4697,6 @@
             <a:srgbClr val="FFFFFF"/>
           </a:solidFill>
           <a:ln/>
-          <a:effectLst>
-            <a:outerShdw sx="100000" sy="100000" kx="0" ky="0" algn="bl" rotWithShape="0" blurRad="50800" dist="25400" dir="8100000">
-              <a:srgbClr val="000000">
-                <a:alpha val="12000"/>
-              </a:srgbClr>
-            </a:outerShdw>
-          </a:effectLst>
         </p:spPr>
       </p:sp>
       <p:sp>
@@ -4938,7 +4707,7 @@
         </p:nvSpPr>
         <p:spPr>
           <a:xfrm>
-            <a:off x="457200" y="2344189"/>
+            <a:off x="457200" y="2207029"/>
             <a:ext cx="45720" cy="330015"/>
           </a:xfrm>
           <a:prstGeom prst="rect">
@@ -4958,8 +4727,8 @@
         </p:nvSpPr>
         <p:spPr>
           <a:xfrm>
-            <a:off x="685800" y="2344189"/>
-            <a:ext cx="7818120" cy="330015"/>
+            <a:off x="640080" y="2207029"/>
+            <a:ext cx="7863840" cy="330015"/>
           </a:xfrm>
           <a:prstGeom prst="rect">
             <a:avLst/>
@@ -4975,7 +4744,7 @@
               <a:buNone/>
             </a:pPr>
             <a:r>
-              <a:rPr lang="en-US" sz="1200" dirty="0">
+              <a:rPr lang="en-US" sz="1100" dirty="0">
                 <a:solidFill>
                   <a:srgbClr val="1A1A2E"/>
                 </a:solidFill>
@@ -4983,9 +4752,9 @@
                 <a:ea typeface="Calibri" pitchFamily="34" charset="-122"/>
                 <a:cs typeface="Calibri" pitchFamily="34" charset="-120"/>
               </a:rPr>
-              <a:t>3. genre_artiste (FK → genre + artiste)</a:t>
-            </a:r>
-            <a:endParaRPr lang="en-US" sz="1200" dirty="0"/>
+              <a:t>  3. genre_artiste (FK → genre + artiste)</a:t>
+            </a:r>
+            <a:endParaRPr lang="en-US" sz="1100" dirty="0"/>
           </a:p>
         </p:txBody>
       </p:sp>
@@ -4997,7 +4766,7 @@
         </p:nvSpPr>
         <p:spPr>
           <a:xfrm>
-            <a:off x="457200" y="2701636"/>
+            <a:off x="457200" y="2564476"/>
             <a:ext cx="8229600" cy="330015"/>
           </a:xfrm>
           <a:prstGeom prst="rect">
@@ -5007,13 +4776,6 @@
             <a:srgbClr val="E3F2FD"/>
           </a:solidFill>
           <a:ln/>
-          <a:effectLst>
-            <a:outerShdw sx="100000" sy="100000" kx="0" ky="0" algn="bl" rotWithShape="0" blurRad="50800" dist="25400" dir="8100000">
-              <a:srgbClr val="000000">
-                <a:alpha val="12000"/>
-              </a:srgbClr>
-            </a:outerShdw>
-          </a:effectLst>
         </p:spPr>
       </p:sp>
       <p:sp>
@@ -5024,7 +4786,7 @@
         </p:nvSpPr>
         <p:spPr>
           <a:xfrm>
-            <a:off x="457200" y="2701636"/>
+            <a:off x="457200" y="2564476"/>
             <a:ext cx="45720" cy="330015"/>
           </a:xfrm>
           <a:prstGeom prst="rect">
@@ -5044,8 +4806,8 @@
         </p:nvSpPr>
         <p:spPr>
           <a:xfrm>
-            <a:off x="685800" y="2701636"/>
-            <a:ext cx="7818120" cy="330015"/>
+            <a:off x="640080" y="2564476"/>
+            <a:ext cx="7863840" cy="330015"/>
           </a:xfrm>
           <a:prstGeom prst="rect">
             <a:avLst/>
@@ -5061,7 +4823,7 @@
               <a:buNone/>
             </a:pPr>
             <a:r>
-              <a:rPr lang="en-US" sz="1200" dirty="0">
+              <a:rPr lang="en-US" sz="1100" dirty="0">
                 <a:solidFill>
                   <a:srgbClr val="1A1A2E"/>
                 </a:solidFill>
@@ -5069,9 +4831,9 @@
                 <a:ea typeface="Calibri" pitchFamily="34" charset="-122"/>
                 <a:cs typeface="Calibri" pitchFamily="34" charset="-120"/>
               </a:rPr>
-              <a:t>4. album (FK → artiste)</a:t>
-            </a:r>
-            <a:endParaRPr lang="en-US" sz="1200" dirty="0"/>
+              <a:t>  4. album (FK → artiste)</a:t>
+            </a:r>
+            <a:endParaRPr lang="en-US" sz="1100" dirty="0"/>
           </a:p>
         </p:txBody>
       </p:sp>
@@ -5083,7 +4845,7 @@
         </p:nvSpPr>
         <p:spPr>
           <a:xfrm>
-            <a:off x="457200" y="3059084"/>
+            <a:off x="457200" y="2921924"/>
             <a:ext cx="8229600" cy="330015"/>
           </a:xfrm>
           <a:prstGeom prst="rect">
@@ -5093,13 +4855,6 @@
             <a:srgbClr val="FFFFFF"/>
           </a:solidFill>
           <a:ln/>
-          <a:effectLst>
-            <a:outerShdw sx="100000" sy="100000" kx="0" ky="0" algn="bl" rotWithShape="0" blurRad="50800" dist="25400" dir="8100000">
-              <a:srgbClr val="000000">
-                <a:alpha val="12000"/>
-              </a:srgbClr>
-            </a:outerShdw>
-          </a:effectLst>
         </p:spPr>
       </p:sp>
       <p:sp>
@@ -5110,7 +4865,7 @@
         </p:nvSpPr>
         <p:spPr>
           <a:xfrm>
-            <a:off x="457200" y="3059084"/>
+            <a:off x="457200" y="2921924"/>
             <a:ext cx="45720" cy="330015"/>
           </a:xfrm>
           <a:prstGeom prst="rect">
@@ -5130,8 +4885,8 @@
         </p:nvSpPr>
         <p:spPr>
           <a:xfrm>
-            <a:off x="685800" y="3059084"/>
-            <a:ext cx="7818120" cy="330015"/>
+            <a:off x="640080" y="2921924"/>
+            <a:ext cx="7863840" cy="330015"/>
           </a:xfrm>
           <a:prstGeom prst="rect">
             <a:avLst/>
@@ -5147,7 +4902,7 @@
               <a:buNone/>
             </a:pPr>
             <a:r>
-              <a:rPr lang="en-US" sz="1200" dirty="0">
+              <a:rPr lang="en-US" sz="1100" dirty="0">
                 <a:solidFill>
                   <a:srgbClr val="1A1A2E"/>
                 </a:solidFill>
@@ -5155,9 +4910,9 @@
                 <a:ea typeface="Calibri" pitchFamily="34" charset="-122"/>
                 <a:cs typeface="Calibri" pitchFamily="34" charset="-120"/>
               </a:rPr>
-              <a:t>5. salle (aucune FK) | ingenieur (aucune FK)</a:t>
-            </a:r>
-            <a:endParaRPr lang="en-US" sz="1200" dirty="0"/>
+              <a:t>  5. salle (aucune FK) | ingenieur (aucune FK)</a:t>
+            </a:r>
+            <a:endParaRPr lang="en-US" sz="1100" dirty="0"/>
           </a:p>
         </p:txBody>
       </p:sp>
@@ -5169,7 +4924,7 @@
         </p:nvSpPr>
         <p:spPr>
           <a:xfrm>
-            <a:off x="457200" y="3416531"/>
+            <a:off x="457200" y="3279371"/>
             <a:ext cx="8229600" cy="330015"/>
           </a:xfrm>
           <a:prstGeom prst="rect">
@@ -5179,13 +4934,6 @@
             <a:srgbClr val="E3F2FD"/>
           </a:solidFill>
           <a:ln/>
-          <a:effectLst>
-            <a:outerShdw sx="100000" sy="100000" kx="0" ky="0" algn="bl" rotWithShape="0" blurRad="50800" dist="25400" dir="8100000">
-              <a:srgbClr val="000000">
-                <a:alpha val="12000"/>
-              </a:srgbClr>
-            </a:outerShdw>
-          </a:effectLst>
         </p:spPr>
       </p:sp>
       <p:sp>
@@ -5196,7 +4944,7 @@
         </p:nvSpPr>
         <p:spPr>
           <a:xfrm>
-            <a:off x="457200" y="3416531"/>
+            <a:off x="457200" y="3279371"/>
             <a:ext cx="45720" cy="330015"/>
           </a:xfrm>
           <a:prstGeom prst="rect">
@@ -5216,8 +4964,8 @@
         </p:nvSpPr>
         <p:spPr>
           <a:xfrm>
-            <a:off x="685800" y="3416531"/>
-            <a:ext cx="7818120" cy="330015"/>
+            <a:off x="640080" y="3279371"/>
+            <a:ext cx="7863840" cy="330015"/>
           </a:xfrm>
           <a:prstGeom prst="rect">
             <a:avLst/>
@@ -5233,7 +4981,7 @@
               <a:buNone/>
             </a:pPr>
             <a:r>
-              <a:rPr lang="en-US" sz="1200" dirty="0">
+              <a:rPr lang="en-US" sz="1100" dirty="0">
                 <a:solidFill>
                   <a:srgbClr val="1A1A2E"/>
                 </a:solidFill>
@@ -5241,9 +4989,9 @@
                 <a:ea typeface="Calibri" pitchFamily="34" charset="-122"/>
                 <a:cs typeface="Calibri" pitchFamily="34" charset="-120"/>
               </a:rPr>
-              <a:t>6. equipement (FK → salle)</a:t>
-            </a:r>
-            <a:endParaRPr lang="en-US" sz="1200" dirty="0"/>
+              <a:t>  6. equipement (FK → salle)</a:t>
+            </a:r>
+            <a:endParaRPr lang="en-US" sz="1100" dirty="0"/>
           </a:p>
         </p:txBody>
       </p:sp>
@@ -5255,7 +5003,7 @@
         </p:nvSpPr>
         <p:spPr>
           <a:xfrm>
-            <a:off x="457200" y="3773978"/>
+            <a:off x="457200" y="3636818"/>
             <a:ext cx="8229600" cy="330015"/>
           </a:xfrm>
           <a:prstGeom prst="rect">
@@ -5265,13 +5013,6 @@
             <a:srgbClr val="FFFFFF"/>
           </a:solidFill>
           <a:ln/>
-          <a:effectLst>
-            <a:outerShdw sx="100000" sy="100000" kx="0" ky="0" algn="bl" rotWithShape="0" blurRad="50800" dist="25400" dir="8100000">
-              <a:srgbClr val="000000">
-                <a:alpha val="12000"/>
-              </a:srgbClr>
-            </a:outerShdw>
-          </a:effectLst>
         </p:spPr>
       </p:sp>
       <p:sp>
@@ -5282,7 +5023,7 @@
         </p:nvSpPr>
         <p:spPr>
           <a:xfrm>
-            <a:off x="457200" y="3773978"/>
+            <a:off x="457200" y="3636818"/>
             <a:ext cx="45720" cy="330015"/>
           </a:xfrm>
           <a:prstGeom prst="rect">
@@ -5302,8 +5043,8 @@
         </p:nvSpPr>
         <p:spPr>
           <a:xfrm>
-            <a:off x="685800" y="3773978"/>
-            <a:ext cx="7818120" cy="330015"/>
+            <a:off x="640080" y="3636818"/>
+            <a:ext cx="7863840" cy="330015"/>
           </a:xfrm>
           <a:prstGeom prst="rect">
             <a:avLst/>
@@ -5319,7 +5060,7 @@
               <a:buNone/>
             </a:pPr>
             <a:r>
-              <a:rPr lang="en-US" sz="1200" dirty="0">
+              <a:rPr lang="en-US" sz="1100" dirty="0">
                 <a:solidFill>
                   <a:srgbClr val="1A1A2E"/>
                 </a:solidFill>
@@ -5327,9 +5068,9 @@
                 <a:ea typeface="Calibri" pitchFamily="34" charset="-122"/>
                 <a:cs typeface="Calibri" pitchFamily="34" charset="-120"/>
               </a:rPr>
-              <a:t>7. session_enregistrement (FK → artiste + salle + ingenieur)</a:t>
-            </a:r>
-            <a:endParaRPr lang="en-US" sz="1200" dirty="0"/>
+              <a:t>  7. session_enregistrement (FK → artiste + salle + ingenieur)</a:t>
+            </a:r>
+            <a:endParaRPr lang="en-US" sz="1100" dirty="0"/>
           </a:p>
         </p:txBody>
       </p:sp>
@@ -5341,7 +5082,7 @@
         </p:nvSpPr>
         <p:spPr>
           <a:xfrm>
-            <a:off x="457200" y="4131425"/>
+            <a:off x="457200" y="3994265"/>
             <a:ext cx="8229600" cy="330015"/>
           </a:xfrm>
           <a:prstGeom prst="rect">
@@ -5351,13 +5092,6 @@
             <a:srgbClr val="E3F2FD"/>
           </a:solidFill>
           <a:ln/>
-          <a:effectLst>
-            <a:outerShdw sx="100000" sy="100000" kx="0" ky="0" algn="bl" rotWithShape="0" blurRad="50800" dist="25400" dir="8100000">
-              <a:srgbClr val="000000">
-                <a:alpha val="12000"/>
-              </a:srgbClr>
-            </a:outerShdw>
-          </a:effectLst>
         </p:spPr>
       </p:sp>
       <p:sp>
@@ -5368,7 +5102,7 @@
         </p:nvSpPr>
         <p:spPr>
           <a:xfrm>
-            <a:off x="457200" y="4131425"/>
+            <a:off x="457200" y="3994265"/>
             <a:ext cx="45720" cy="330015"/>
           </a:xfrm>
           <a:prstGeom prst="rect">
@@ -5388,8 +5122,8 @@
         </p:nvSpPr>
         <p:spPr>
           <a:xfrm>
-            <a:off x="685800" y="4131425"/>
-            <a:ext cx="7818120" cy="330015"/>
+            <a:off x="640080" y="3994265"/>
+            <a:ext cx="7863840" cy="330015"/>
           </a:xfrm>
           <a:prstGeom prst="rect">
             <a:avLst/>
@@ -5405,7 +5139,7 @@
               <a:buNone/>
             </a:pPr>
             <a:r>
-              <a:rPr lang="en-US" sz="1200" dirty="0">
+              <a:rPr lang="en-US" sz="1100" dirty="0">
                 <a:solidFill>
                   <a:srgbClr val="1A1A2E"/>
                 </a:solidFill>
@@ -5413,9 +5147,9 @@
                 <a:ea typeface="Calibri" pitchFamily="34" charset="-122"/>
                 <a:cs typeface="Calibri" pitchFamily="34" charset="-120"/>
               </a:rPr>
-              <a:t>8. facture (FK → artiste + session)</a:t>
-            </a:r>
-            <a:endParaRPr lang="en-US" sz="1200" dirty="0"/>
+              <a:t>  8. facture (FK → artiste + session)</a:t>
+            </a:r>
+            <a:endParaRPr lang="en-US" sz="1100" dirty="0"/>
           </a:p>
         </p:txBody>
       </p:sp>
@@ -5427,7 +5161,7 @@
         </p:nvSpPr>
         <p:spPr>
           <a:xfrm>
-            <a:off x="457200" y="4488873"/>
+            <a:off x="457200" y="4351713"/>
             <a:ext cx="8229600" cy="330015"/>
           </a:xfrm>
           <a:prstGeom prst="rect">
@@ -5437,13 +5171,6 @@
             <a:srgbClr val="FFFFFF"/>
           </a:solidFill>
           <a:ln/>
-          <a:effectLst>
-            <a:outerShdw sx="100000" sy="100000" kx="0" ky="0" algn="bl" rotWithShape="0" blurRad="50800" dist="25400" dir="8100000">
-              <a:srgbClr val="000000">
-                <a:alpha val="12000"/>
-              </a:srgbClr>
-            </a:outerShdw>
-          </a:effectLst>
         </p:spPr>
       </p:sp>
       <p:sp>
@@ -5454,7 +5181,7 @@
         </p:nvSpPr>
         <p:spPr>
           <a:xfrm>
-            <a:off x="457200" y="4488873"/>
+            <a:off x="457200" y="4351713"/>
             <a:ext cx="45720" cy="330015"/>
           </a:xfrm>
           <a:prstGeom prst="rect">
@@ -5474,8 +5201,8 @@
         </p:nvSpPr>
         <p:spPr>
           <a:xfrm>
-            <a:off x="685800" y="4488873"/>
-            <a:ext cx="7818120" cy="330015"/>
+            <a:off x="640080" y="4351713"/>
+            <a:ext cx="7863840" cy="330015"/>
           </a:xfrm>
           <a:prstGeom prst="rect">
             <a:avLst/>
@@ -5491,7 +5218,7 @@
               <a:buNone/>
             </a:pPr>
             <a:r>
-              <a:rPr lang="en-US" sz="1200" dirty="0">
+              <a:rPr lang="en-US" sz="1100" dirty="0">
                 <a:solidFill>
                   <a:srgbClr val="1A1A2E"/>
                 </a:solidFill>
@@ -5499,9 +5226,9 @@
                 <a:ea typeface="Calibri" pitchFamily="34" charset="-122"/>
                 <a:cs typeface="Calibri" pitchFamily="34" charset="-120"/>
               </a:rPr>
-              <a:t>Script de suppression : ORDRE INVERSE !</a:t>
-            </a:r>
-            <a:endParaRPr lang="en-US" sz="1200" dirty="0"/>
+              <a:t>Script de SUPPRESSION : ORDRE INVERSE !</a:t>
+            </a:r>
+            <a:endParaRPr lang="en-US" sz="1100" dirty="0"/>
           </a:p>
         </p:txBody>
       </p:sp>
@@ -5566,7 +5293,7 @@
         <p:spPr>
           <a:xfrm>
             <a:off x="457200" y="182880"/>
-            <a:ext cx="8229600" cy="594360"/>
+            <a:ext cx="8229600" cy="502920"/>
           </a:xfrm>
           <a:prstGeom prst="rect">
             <a:avLst/>
@@ -5582,7 +5309,7 @@
               <a:buNone/>
             </a:pPr>
             <a:r>
-              <a:rPr lang="en-US" sz="2400" b="1" dirty="0">
+              <a:rPr lang="en-US" sz="2100" b="1" dirty="0">
                 <a:solidFill>
                   <a:srgbClr val="0D47A1"/>
                 </a:solidFill>
@@ -5590,9 +5317,9 @@
                 <a:ea typeface="Trebuchet MS" pitchFamily="34" charset="-122"/>
                 <a:cs typeface="Trebuchet MS" pitchFamily="34" charset="-120"/>
               </a:rPr>
-              <a:t>Astuces et bonnes pratiques</a:t>
-            </a:r>
-            <a:endParaRPr lang="en-US" sz="2400" dirty="0"/>
+              <a:t>Bonnes pratiques et astuces</a:t>
+            </a:r>
+            <a:endParaRPr lang="en-US" sz="2100" dirty="0"/>
           </a:p>
         </p:txBody>
       </p:sp>
@@ -5604,8 +5331,8 @@
         </p:nvSpPr>
         <p:spPr>
           <a:xfrm>
-            <a:off x="457200" y="914400"/>
-            <a:ext cx="8229600" cy="521208"/>
+            <a:off x="457200" y="777240"/>
+            <a:ext cx="8229600" cy="448056"/>
           </a:xfrm>
           <a:prstGeom prst="rect">
             <a:avLst/>
@@ -5614,13 +5341,6 @@
             <a:srgbClr val="FFFFFF"/>
           </a:solidFill>
           <a:ln/>
-          <a:effectLst>
-            <a:outerShdw sx="100000" sy="100000" kx="0" ky="0" algn="bl" rotWithShape="0" blurRad="50800" dist="25400" dir="8100000">
-              <a:srgbClr val="000000">
-                <a:alpha val="12000"/>
-              </a:srgbClr>
-            </a:outerShdw>
-          </a:effectLst>
         </p:spPr>
       </p:sp>
       <p:sp>
@@ -5631,8 +5351,8 @@
         </p:nvSpPr>
         <p:spPr>
           <a:xfrm>
-            <a:off x="457200" y="914400"/>
-            <a:ext cx="45720" cy="521208"/>
+            <a:off x="457200" y="777240"/>
+            <a:ext cx="45720" cy="448056"/>
           </a:xfrm>
           <a:prstGeom prst="rect">
             <a:avLst/>
@@ -5651,8 +5371,8 @@
         </p:nvSpPr>
         <p:spPr>
           <a:xfrm>
-            <a:off x="685800" y="914400"/>
-            <a:ext cx="7818120" cy="521208"/>
+            <a:off x="640080" y="777240"/>
+            <a:ext cx="7863840" cy="448056"/>
           </a:xfrm>
           <a:prstGeom prst="rect">
             <a:avLst/>
@@ -5676,7 +5396,7 @@
                 <a:ea typeface="JetBrains Mono" pitchFamily="34" charset="-122"/>
                 <a:cs typeface="JetBrains Mono" pitchFamily="34" charset="-120"/>
               </a:rPr>
-              <a:t>DROP TABLE IF EXISTS artiste;  — pas d'erreur si la table n'existe pas</a:t>
+              <a:t>DROP TABLE IF EXISTS artiste; — pas d'erreur si absente</a:t>
             </a:r>
             <a:endParaRPr lang="en-US" sz="1000" dirty="0"/>
           </a:p>
@@ -5690,8 +5410,8 @@
         </p:nvSpPr>
         <p:spPr>
           <a:xfrm>
-            <a:off x="457200" y="1463040"/>
-            <a:ext cx="8229600" cy="521208"/>
+            <a:off x="457200" y="1252728"/>
+            <a:ext cx="8229600" cy="448056"/>
           </a:xfrm>
           <a:prstGeom prst="rect">
             <a:avLst/>
@@ -5700,13 +5420,6 @@
             <a:srgbClr val="E3F2FD"/>
           </a:solidFill>
           <a:ln/>
-          <a:effectLst>
-            <a:outerShdw sx="100000" sy="100000" kx="0" ky="0" algn="bl" rotWithShape="0" blurRad="50800" dist="25400" dir="8100000">
-              <a:srgbClr val="000000">
-                <a:alpha val="12000"/>
-              </a:srgbClr>
-            </a:outerShdw>
-          </a:effectLst>
         </p:spPr>
       </p:sp>
       <p:sp>
@@ -5717,8 +5430,8 @@
         </p:nvSpPr>
         <p:spPr>
           <a:xfrm>
-            <a:off x="457200" y="1463040"/>
-            <a:ext cx="45720" cy="521208"/>
+            <a:off x="457200" y="1252728"/>
+            <a:ext cx="45720" cy="448056"/>
           </a:xfrm>
           <a:prstGeom prst="rect">
             <a:avLst/>
@@ -5737,8 +5450,8 @@
         </p:nvSpPr>
         <p:spPr>
           <a:xfrm>
-            <a:off x="685800" y="1463040"/>
-            <a:ext cx="7818120" cy="521208"/>
+            <a:off x="640080" y="1252728"/>
+            <a:ext cx="7863840" cy="448056"/>
           </a:xfrm>
           <a:prstGeom prst="rect">
             <a:avLst/>
@@ -5762,7 +5475,7 @@
                 <a:ea typeface="JetBrains Mono" pitchFamily="34" charset="-122"/>
                 <a:cs typeface="JetBrains Mono" pitchFamily="34" charset="-120"/>
               </a:rPr>
-              <a:t>CREATE TABLE IF NOT EXISTS artiste ...;  — idem pour la création</a:t>
+              <a:t>CREATE TABLE IF NOT EXISTS artiste; — idem pour creation</a:t>
             </a:r>
             <a:endParaRPr lang="en-US" sz="1000" dirty="0"/>
           </a:p>
@@ -5776,8 +5489,8 @@
         </p:nvSpPr>
         <p:spPr>
           <a:xfrm>
-            <a:off x="457200" y="2011680"/>
-            <a:ext cx="8229600" cy="521208"/>
+            <a:off x="457200" y="1728216"/>
+            <a:ext cx="8229600" cy="448056"/>
           </a:xfrm>
           <a:prstGeom prst="rect">
             <a:avLst/>
@@ -5786,13 +5499,6 @@
             <a:srgbClr val="FFFFFF"/>
           </a:solidFill>
           <a:ln/>
-          <a:effectLst>
-            <a:outerShdw sx="100000" sy="100000" kx="0" ky="0" algn="bl" rotWithShape="0" blurRad="50800" dist="25400" dir="8100000">
-              <a:srgbClr val="000000">
-                <a:alpha val="12000"/>
-              </a:srgbClr>
-            </a:outerShdw>
-          </a:effectLst>
         </p:spPr>
       </p:sp>
       <p:sp>
@@ -5803,8 +5509,8 @@
         </p:nvSpPr>
         <p:spPr>
           <a:xfrm>
-            <a:off x="457200" y="2011680"/>
-            <a:ext cx="45720" cy="521208"/>
+            <a:off x="457200" y="1728216"/>
+            <a:ext cx="45720" cy="448056"/>
           </a:xfrm>
           <a:prstGeom prst="rect">
             <a:avLst/>
@@ -5823,8 +5529,8 @@
         </p:nvSpPr>
         <p:spPr>
           <a:xfrm>
-            <a:off x="685800" y="2011680"/>
-            <a:ext cx="7818120" cy="521208"/>
+            <a:off x="640080" y="1728216"/>
+            <a:ext cx="7863840" cy="448056"/>
           </a:xfrm>
           <a:prstGeom prst="rect">
             <a:avLst/>
@@ -5840,7 +5546,7 @@
               <a:buNone/>
             </a:pPr>
             <a:r>
-              <a:rPr lang="en-US" sz="1200" dirty="0">
+              <a:rPr lang="en-US" sz="1100" dirty="0">
                 <a:solidFill>
                   <a:srgbClr val="1A1A2E"/>
                 </a:solidFill>
@@ -5848,9 +5554,9 @@
                 <a:ea typeface="Calibri" pitchFamily="34" charset="-122"/>
                 <a:cs typeface="Calibri" pitchFamily="34" charset="-120"/>
               </a:rPr>
-              <a:t>COMMENT = 'description' — documenter chaque table et colonne</a:t>
-            </a:r>
-            <a:endParaRPr lang="en-US" sz="1200" dirty="0"/>
+              <a:t>COMMENT = 'description' — documenter chaque table</a:t>
+            </a:r>
+            <a:endParaRPr lang="en-US" sz="1100" dirty="0"/>
           </a:p>
         </p:txBody>
       </p:sp>
@@ -5862,8 +5568,8 @@
         </p:nvSpPr>
         <p:spPr>
           <a:xfrm>
-            <a:off x="457200" y="2560320"/>
-            <a:ext cx="8229600" cy="521208"/>
+            <a:off x="457200" y="2203704"/>
+            <a:ext cx="8229600" cy="448056"/>
           </a:xfrm>
           <a:prstGeom prst="rect">
             <a:avLst/>
@@ -5872,13 +5578,6 @@
             <a:srgbClr val="E3F2FD"/>
           </a:solidFill>
           <a:ln/>
-          <a:effectLst>
-            <a:outerShdw sx="100000" sy="100000" kx="0" ky="0" algn="bl" rotWithShape="0" blurRad="50800" dist="25400" dir="8100000">
-              <a:srgbClr val="000000">
-                <a:alpha val="12000"/>
-              </a:srgbClr>
-            </a:outerShdw>
-          </a:effectLst>
         </p:spPr>
       </p:sp>
       <p:sp>
@@ -5889,8 +5588,8 @@
         </p:nvSpPr>
         <p:spPr>
           <a:xfrm>
-            <a:off x="457200" y="2560320"/>
-            <a:ext cx="45720" cy="521208"/>
+            <a:off x="457200" y="2203704"/>
+            <a:ext cx="45720" cy="448056"/>
           </a:xfrm>
           <a:prstGeom prst="rect">
             <a:avLst/>
@@ -5909,8 +5608,8 @@
         </p:nvSpPr>
         <p:spPr>
           <a:xfrm>
-            <a:off x="685800" y="2560320"/>
-            <a:ext cx="7818120" cy="521208"/>
+            <a:off x="640080" y="2203704"/>
+            <a:ext cx="7863840" cy="448056"/>
           </a:xfrm>
           <a:prstGeom prst="rect">
             <a:avLst/>
@@ -5934,7 +5633,7 @@
                 <a:ea typeface="JetBrains Mono" pitchFamily="34" charset="-122"/>
                 <a:cs typeface="JetBrains Mono" pitchFamily="34" charset="-120"/>
               </a:rPr>
-              <a:t>AUTO_INCREMENT commence à 1 par défaut</a:t>
+              <a:t>AUTO_INCREMENT commence a 1 par defaut</a:t>
             </a:r>
             <a:endParaRPr lang="en-US" sz="1000" dirty="0"/>
           </a:p>
@@ -5948,8 +5647,8 @@
         </p:nvSpPr>
         <p:spPr>
           <a:xfrm>
-            <a:off x="457200" y="3108960"/>
-            <a:ext cx="8229600" cy="521208"/>
+            <a:off x="457200" y="2679192"/>
+            <a:ext cx="8229600" cy="448056"/>
           </a:xfrm>
           <a:prstGeom prst="rect">
             <a:avLst/>
@@ -5958,13 +5657,6 @@
             <a:srgbClr val="FFFFFF"/>
           </a:solidFill>
           <a:ln/>
-          <a:effectLst>
-            <a:outerShdw sx="100000" sy="100000" kx="0" ky="0" algn="bl" rotWithShape="0" blurRad="50800" dist="25400" dir="8100000">
-              <a:srgbClr val="000000">
-                <a:alpha val="12000"/>
-              </a:srgbClr>
-            </a:outerShdw>
-          </a:effectLst>
         </p:spPr>
       </p:sp>
       <p:sp>
@@ -5975,8 +5667,8 @@
         </p:nvSpPr>
         <p:spPr>
           <a:xfrm>
-            <a:off x="457200" y="3108960"/>
-            <a:ext cx="45720" cy="521208"/>
+            <a:off x="457200" y="2679192"/>
+            <a:ext cx="45720" cy="448056"/>
           </a:xfrm>
           <a:prstGeom prst="rect">
             <a:avLst/>
@@ -5995,8 +5687,8 @@
         </p:nvSpPr>
         <p:spPr>
           <a:xfrm>
-            <a:off x="685800" y="3108960"/>
-            <a:ext cx="7818120" cy="521208"/>
+            <a:off x="640080" y="2679192"/>
+            <a:ext cx="7863840" cy="448056"/>
           </a:xfrm>
           <a:prstGeom prst="rect">
             <a:avLst/>
@@ -6012,7 +5704,7 @@
               <a:buNone/>
             </a:pPr>
             <a:r>
-              <a:rPr lang="en-US" sz="1200" dirty="0">
+              <a:rPr lang="en-US" sz="1100" dirty="0">
                 <a:solidFill>
                   <a:srgbClr val="1A1A2E"/>
                 </a:solidFill>
@@ -6020,9 +5712,9 @@
                 <a:ea typeface="Calibri" pitchFamily="34" charset="-122"/>
                 <a:cs typeface="Calibri" pitchFamily="34" charset="-120"/>
               </a:rPr>
-              <a:t>CHARACTER SET utf8mb4 — support des accents et emojis</a:t>
-            </a:r>
-            <a:endParaRPr lang="en-US" sz="1200" dirty="0"/>
+              <a:t>CHARACTER SET utf8mb4 — accents et emojis</a:t>
+            </a:r>
+            <a:endParaRPr lang="en-US" sz="1100" dirty="0"/>
           </a:p>
         </p:txBody>
       </p:sp>
@@ -6034,8 +5726,8 @@
         </p:nvSpPr>
         <p:spPr>
           <a:xfrm>
-            <a:off x="457200" y="3657600"/>
-            <a:ext cx="8229600" cy="521208"/>
+            <a:off x="457200" y="3154680"/>
+            <a:ext cx="8229600" cy="448056"/>
           </a:xfrm>
           <a:prstGeom prst="rect">
             <a:avLst/>
@@ -6044,13 +5736,6 @@
             <a:srgbClr val="E3F2FD"/>
           </a:solidFill>
           <a:ln/>
-          <a:effectLst>
-            <a:outerShdw sx="100000" sy="100000" kx="0" ky="0" algn="bl" rotWithShape="0" blurRad="50800" dist="25400" dir="8100000">
-              <a:srgbClr val="000000">
-                <a:alpha val="12000"/>
-              </a:srgbClr>
-            </a:outerShdw>
-          </a:effectLst>
         </p:spPr>
       </p:sp>
       <p:sp>
@@ -6061,8 +5746,8 @@
         </p:nvSpPr>
         <p:spPr>
           <a:xfrm>
-            <a:off x="457200" y="3657600"/>
-            <a:ext cx="45720" cy="521208"/>
+            <a:off x="457200" y="3154680"/>
+            <a:ext cx="45720" cy="448056"/>
           </a:xfrm>
           <a:prstGeom prst="rect">
             <a:avLst/>
@@ -6081,8 +5766,8 @@
         </p:nvSpPr>
         <p:spPr>
           <a:xfrm>
-            <a:off x="685800" y="3657600"/>
-            <a:ext cx="7818120" cy="521208"/>
+            <a:off x="640080" y="3154680"/>
+            <a:ext cx="7863840" cy="448056"/>
           </a:xfrm>
           <a:prstGeom prst="rect">
             <a:avLst/>
@@ -6098,7 +5783,7 @@
               <a:buNone/>
             </a:pPr>
             <a:r>
-              <a:rPr lang="en-US" sz="1200" dirty="0">
+              <a:rPr lang="en-US" sz="1100" dirty="0">
                 <a:solidFill>
                   <a:srgbClr val="1A1A2E"/>
                 </a:solidFill>
@@ -6106,9 +5791,9 @@
                 <a:ea typeface="Calibri" pitchFamily="34" charset="-122"/>
                 <a:cs typeface="Calibri" pitchFamily="34" charset="-120"/>
               </a:rPr>
-              <a:t>Utiliser des noms en minuscules avec underscores : session_enregistrement</a:t>
-            </a:r>
-            <a:endParaRPr lang="en-US" sz="1200" dirty="0"/>
+              <a:t>Noms en minuscules avec underscores : session_enregistrement</a:t>
+            </a:r>
+            <a:endParaRPr lang="en-US" sz="1100" dirty="0"/>
           </a:p>
         </p:txBody>
       </p:sp>
@@ -6120,8 +5805,8 @@
         </p:nvSpPr>
         <p:spPr>
           <a:xfrm>
-            <a:off x="457200" y="4206240"/>
-            <a:ext cx="8229600" cy="521208"/>
+            <a:off x="457200" y="3630168"/>
+            <a:ext cx="8229600" cy="448056"/>
           </a:xfrm>
           <a:prstGeom prst="rect">
             <a:avLst/>
@@ -6130,13 +5815,6 @@
             <a:srgbClr val="FFFFFF"/>
           </a:solidFill>
           <a:ln/>
-          <a:effectLst>
-            <a:outerShdw sx="100000" sy="100000" kx="0" ky="0" algn="bl" rotWithShape="0" blurRad="50800" dist="25400" dir="8100000">
-              <a:srgbClr val="000000">
-                <a:alpha val="12000"/>
-              </a:srgbClr>
-            </a:outerShdw>
-          </a:effectLst>
         </p:spPr>
       </p:sp>
       <p:sp>
@@ -6147,8 +5825,8 @@
         </p:nvSpPr>
         <p:spPr>
           <a:xfrm>
-            <a:off x="457200" y="4206240"/>
-            <a:ext cx="45720" cy="521208"/>
+            <a:off x="457200" y="3630168"/>
+            <a:ext cx="45720" cy="448056"/>
           </a:xfrm>
           <a:prstGeom prst="rect">
             <a:avLst/>
@@ -6167,8 +5845,8 @@
         </p:nvSpPr>
         <p:spPr>
           <a:xfrm>
-            <a:off x="685800" y="4206240"/>
-            <a:ext cx="7818120" cy="521208"/>
+            <a:off x="640080" y="3630168"/>
+            <a:ext cx="7863840" cy="448056"/>
           </a:xfrm>
           <a:prstGeom prst="rect">
             <a:avLst/>
@@ -6184,7 +5862,7 @@
               <a:buNone/>
             </a:pPr>
             <a:r>
-              <a:rPr lang="en-US" sz="1200" dirty="0">
+              <a:rPr lang="en-US" sz="1100" dirty="0">
                 <a:solidFill>
                   <a:srgbClr val="1A1A2E"/>
                 </a:solidFill>
@@ -6192,9 +5870,88 @@
                 <a:ea typeface="Calibri" pitchFamily="34" charset="-122"/>
                 <a:cs typeface="Calibri" pitchFamily="34" charset="-120"/>
               </a:rPr>
-              <a:t>Préfixer les contraintes : fk_album_artiste, chk_prix</a:t>
-            </a:r>
-            <a:endParaRPr lang="en-US" sz="1200" dirty="0"/>
+              <a:t>Prefixer les contraintes : fk_album_artiste, chk_prix</a:t>
+            </a:r>
+            <a:endParaRPr lang="en-US" sz="1100" dirty="0"/>
+          </a:p>
+        </p:txBody>
+      </p:sp>
+      <p:sp>
+        <p:nvSpPr>
+          <p:cNvPr id="25" name="Shape 23"/>
+          <p:cNvSpPr/>
+          <p:nvPr/>
+        </p:nvSpPr>
+        <p:spPr>
+          <a:xfrm>
+            <a:off x="457200" y="4105656"/>
+            <a:ext cx="8229600" cy="448056"/>
+          </a:xfrm>
+          <a:prstGeom prst="rect">
+            <a:avLst/>
+          </a:prstGeom>
+          <a:solidFill>
+            <a:srgbClr val="E3F2FD"/>
+          </a:solidFill>
+          <a:ln/>
+        </p:spPr>
+      </p:sp>
+      <p:sp>
+        <p:nvSpPr>
+          <p:cNvPr id="26" name="Shape 24"/>
+          <p:cNvSpPr/>
+          <p:nvPr/>
+        </p:nvSpPr>
+        <p:spPr>
+          <a:xfrm>
+            <a:off x="457200" y="4105656"/>
+            <a:ext cx="45720" cy="448056"/>
+          </a:xfrm>
+          <a:prstGeom prst="rect">
+            <a:avLst/>
+          </a:prstGeom>
+          <a:solidFill>
+            <a:srgbClr val="1565C0"/>
+          </a:solidFill>
+          <a:ln/>
+        </p:spPr>
+      </p:sp>
+      <p:sp>
+        <p:nvSpPr>
+          <p:cNvPr id="27" name="Text 25"/>
+          <p:cNvSpPr/>
+          <p:nvPr/>
+        </p:nvSpPr>
+        <p:spPr>
+          <a:xfrm>
+            <a:off x="640080" y="4105656"/>
+            <a:ext cx="7863840" cy="448056"/>
+          </a:xfrm>
+          <a:prstGeom prst="rect">
+            <a:avLst/>
+          </a:prstGeom>
+          <a:noFill/>
+          <a:ln/>
+        </p:spPr>
+        <p:txBody>
+          <a:bodyPr wrap="square" lIns="0" tIns="0" rIns="0" bIns="0" rtlCol="0" anchor="ctr"/>
+          <a:lstStyle/>
+          <a:p>
+            <a:pPr indent="0" marL="0">
+              <a:buNone/>
+            </a:pPr>
+            <a:r>
+              <a:rPr lang="en-US" sz="1100" dirty="0">
+                <a:solidFill>
+                  <a:srgbClr val="1A1A2E"/>
+                </a:solidFill>
+                <a:latin typeface="Calibri" pitchFamily="34" charset="0"/>
+                <a:ea typeface="Calibri" pitchFamily="34" charset="-122"/>
+                <a:cs typeface="Calibri" pitchFamily="34" charset="-120"/>
+              </a:rPr>
+              <a:t>Utiliser SHOW CREATE TABLE pour verifier</a:t>
+            </a:r>
+            <a:endParaRPr lang="en-US" sz="1100" dirty="0"/>
           </a:p>
         </p:txBody>
       </p:sp>
@@ -6259,7 +6016,7 @@
         <p:spPr>
           <a:xfrm>
             <a:off x="457200" y="182880"/>
-            <a:ext cx="8229600" cy="594360"/>
+            <a:ext cx="8229600" cy="502920"/>
           </a:xfrm>
           <a:prstGeom prst="rect">
             <a:avLst/>
@@ -6275,7 +6032,7 @@
               <a:buNone/>
             </a:pPr>
             <a:r>
-              <a:rPr lang="en-US" sz="2400" b="1" dirty="0">
+              <a:rPr lang="en-US" sz="2100" b="1" dirty="0">
                 <a:solidFill>
                   <a:srgbClr val="0D47A1"/>
                 </a:solidFill>
@@ -6283,9 +6040,9 @@
                 <a:ea typeface="Trebuchet MS" pitchFamily="34" charset="-122"/>
                 <a:cs typeface="Trebuchet MS" pitchFamily="34" charset="-120"/>
               </a:rPr>
-              <a:t>Exercice Module 9 : créer SwissSound</a:t>
-            </a:r>
-            <a:endParaRPr lang="en-US" sz="2400" dirty="0"/>
+              <a:t>Exercices sur GESCOM et SwissSound</a:t>
+            </a:r>
+            <a:endParaRPr lang="en-US" sz="2100" dirty="0"/>
           </a:p>
         </p:txBody>
       </p:sp>
@@ -6297,8 +6054,8 @@
         </p:nvSpPr>
         <p:spPr>
           <a:xfrm>
-            <a:off x="457200" y="914400"/>
-            <a:ext cx="8229600" cy="521208"/>
+            <a:off x="457200" y="777240"/>
+            <a:ext cx="8229600" cy="448056"/>
           </a:xfrm>
           <a:prstGeom prst="rect">
             <a:avLst/>
@@ -6307,13 +6064,6 @@
             <a:srgbClr val="FFFFFF"/>
           </a:solidFill>
           <a:ln/>
-          <a:effectLst>
-            <a:outerShdw sx="100000" sy="100000" kx="0" ky="0" algn="bl" rotWithShape="0" blurRad="50800" dist="25400" dir="8100000">
-              <a:srgbClr val="000000">
-                <a:alpha val="12000"/>
-              </a:srgbClr>
-            </a:outerShdw>
-          </a:effectLst>
         </p:spPr>
       </p:sp>
       <p:sp>
@@ -6324,8 +6074,8 @@
         </p:nvSpPr>
         <p:spPr>
           <a:xfrm>
-            <a:off x="457200" y="914400"/>
-            <a:ext cx="45720" cy="521208"/>
+            <a:off x="457200" y="777240"/>
+            <a:ext cx="45720" cy="448056"/>
           </a:xfrm>
           <a:prstGeom prst="rect">
             <a:avLst/>
@@ -6344,8 +6094,8 @@
         </p:nvSpPr>
         <p:spPr>
           <a:xfrm>
-            <a:off x="685800" y="914400"/>
-            <a:ext cx="7818120" cy="521208"/>
+            <a:off x="640080" y="777240"/>
+            <a:ext cx="7863840" cy="448056"/>
           </a:xfrm>
           <a:prstGeom prst="rect">
             <a:avLst/>
@@ -6361,7 +6111,7 @@
               <a:buNone/>
             </a:pPr>
             <a:r>
-              <a:rPr lang="en-US" sz="1200" dirty="0">
+              <a:rPr lang="en-US" sz="1100" dirty="0">
                 <a:solidFill>
                   <a:srgbClr val="1A1A2E"/>
                 </a:solidFill>
@@ -6369,9 +6119,9 @@
                 <a:ea typeface="Calibri" pitchFamily="34" charset="-122"/>
                 <a:cs typeface="Calibri" pitchFamily="34" charset="-120"/>
               </a:rPr>
-              <a:t>Écrire le script DDL complet (CREATE DATABASE + 9 tables)</a:t>
-            </a:r>
-            <a:endParaRPr lang="en-US" sz="1200" dirty="0"/>
+              <a:t>1. Ecrire le script DDL complet SwissSound (9 tables)</a:t>
+            </a:r>
+            <a:endParaRPr lang="en-US" sz="1100" dirty="0"/>
           </a:p>
         </p:txBody>
       </p:sp>
@@ -6383,8 +6133,8 @@
         </p:nvSpPr>
         <p:spPr>
           <a:xfrm>
-            <a:off x="457200" y="1463040"/>
-            <a:ext cx="8229600" cy="521208"/>
+            <a:off x="457200" y="1252728"/>
+            <a:ext cx="8229600" cy="448056"/>
           </a:xfrm>
           <a:prstGeom prst="rect">
             <a:avLst/>
@@ -6393,13 +6143,6 @@
             <a:srgbClr val="E3F2FD"/>
           </a:solidFill>
           <a:ln/>
-          <a:effectLst>
-            <a:outerShdw sx="100000" sy="100000" kx="0" ky="0" algn="bl" rotWithShape="0" blurRad="50800" dist="25400" dir="8100000">
-              <a:srgbClr val="000000">
-                <a:alpha val="12000"/>
-              </a:srgbClr>
-            </a:outerShdw>
-          </a:effectLst>
         </p:spPr>
       </p:sp>
       <p:sp>
@@ -6410,8 +6153,8 @@
         </p:nvSpPr>
         <p:spPr>
           <a:xfrm>
-            <a:off x="457200" y="1463040"/>
-            <a:ext cx="45720" cy="521208"/>
+            <a:off x="457200" y="1252728"/>
+            <a:ext cx="45720" cy="448056"/>
           </a:xfrm>
           <a:prstGeom prst="rect">
             <a:avLst/>
@@ -6430,8 +6173,8 @@
         </p:nvSpPr>
         <p:spPr>
           <a:xfrm>
-            <a:off x="685800" y="1463040"/>
-            <a:ext cx="7818120" cy="521208"/>
+            <a:off x="640080" y="1252728"/>
+            <a:ext cx="7863840" cy="448056"/>
           </a:xfrm>
           <a:prstGeom prst="rect">
             <a:avLst/>
@@ -6447,7 +6190,7 @@
               <a:buNone/>
             </a:pPr>
             <a:r>
-              <a:rPr lang="en-US" sz="1200" dirty="0">
+              <a:rPr lang="en-US" sz="1100" dirty="0">
                 <a:solidFill>
                   <a:srgbClr val="1A1A2E"/>
                 </a:solidFill>
@@ -6455,9 +6198,9 @@
                 <a:ea typeface="Calibri" pitchFamily="34" charset="-122"/>
                 <a:cs typeface="Calibri" pitchFamily="34" charset="-120"/>
               </a:rPr>
-              <a:t>Respecter l'ordre de création (FK)</a:t>
-            </a:r>
-            <a:endParaRPr lang="en-US" sz="1200" dirty="0"/>
+              <a:t>2. Respecter l'ordre de creation (FK)</a:t>
+            </a:r>
+            <a:endParaRPr lang="en-US" sz="1100" dirty="0"/>
           </a:p>
         </p:txBody>
       </p:sp>
@@ -6469,8 +6212,8 @@
         </p:nvSpPr>
         <p:spPr>
           <a:xfrm>
-            <a:off x="457200" y="2011680"/>
-            <a:ext cx="8229600" cy="521208"/>
+            <a:off x="457200" y="1728216"/>
+            <a:ext cx="8229600" cy="448056"/>
           </a:xfrm>
           <a:prstGeom prst="rect">
             <a:avLst/>
@@ -6479,13 +6222,6 @@
             <a:srgbClr val="FFFFFF"/>
           </a:solidFill>
           <a:ln/>
-          <a:effectLst>
-            <a:outerShdw sx="100000" sy="100000" kx="0" ky="0" algn="bl" rotWithShape="0" blurRad="50800" dist="25400" dir="8100000">
-              <a:srgbClr val="000000">
-                <a:alpha val="12000"/>
-              </a:srgbClr>
-            </a:outerShdw>
-          </a:effectLst>
         </p:spPr>
       </p:sp>
       <p:sp>
@@ -6496,8 +6232,8 @@
         </p:nvSpPr>
         <p:spPr>
           <a:xfrm>
-            <a:off x="457200" y="2011680"/>
-            <a:ext cx="45720" cy="521208"/>
+            <a:off x="457200" y="1728216"/>
+            <a:ext cx="45720" cy="448056"/>
           </a:xfrm>
           <a:prstGeom prst="rect">
             <a:avLst/>
@@ -6516,8 +6252,8 @@
         </p:nvSpPr>
         <p:spPr>
           <a:xfrm>
-            <a:off x="685800" y="2011680"/>
-            <a:ext cx="7818120" cy="521208"/>
+            <a:off x="640080" y="1728216"/>
+            <a:ext cx="7863840" cy="448056"/>
           </a:xfrm>
           <a:prstGeom prst="rect">
             <a:avLst/>
@@ -6533,7 +6269,7 @@
               <a:buNone/>
             </a:pPr>
             <a:r>
-              <a:rPr lang="en-US" sz="1200" dirty="0">
+              <a:rPr lang="en-US" sz="1100" dirty="0">
                 <a:solidFill>
                   <a:srgbClr val="1A1A2E"/>
                 </a:solidFill>
@@ -6541,9 +6277,9 @@
                 <a:ea typeface="Calibri" pitchFamily="34" charset="-122"/>
                 <a:cs typeface="Calibri" pitchFamily="34" charset="-120"/>
               </a:rPr>
-              <a:t>Ajouter toutes les contraintes PK, FK, NOT NULL, UNIQUE, CHECK, DEFAULT</a:t>
-            </a:r>
-            <a:endParaRPr lang="en-US" sz="1200" dirty="0"/>
+              <a:t>3. Ajouter toutes les contraintes PK, FK, NOT NULL, UNIQUE, CHECK, DEFAULT</a:t>
+            </a:r>
+            <a:endParaRPr lang="en-US" sz="1100" dirty="0"/>
           </a:p>
         </p:txBody>
       </p:sp>
@@ -6555,8 +6291,8 @@
         </p:nvSpPr>
         <p:spPr>
           <a:xfrm>
-            <a:off x="457200" y="2560320"/>
-            <a:ext cx="8229600" cy="521208"/>
+            <a:off x="457200" y="2203704"/>
+            <a:ext cx="8229600" cy="448056"/>
           </a:xfrm>
           <a:prstGeom prst="rect">
             <a:avLst/>
@@ -6565,13 +6301,6 @@
             <a:srgbClr val="E3F2FD"/>
           </a:solidFill>
           <a:ln/>
-          <a:effectLst>
-            <a:outerShdw sx="100000" sy="100000" kx="0" ky="0" algn="bl" rotWithShape="0" blurRad="50800" dist="25400" dir="8100000">
-              <a:srgbClr val="000000">
-                <a:alpha val="12000"/>
-              </a:srgbClr>
-            </a:outerShdw>
-          </a:effectLst>
         </p:spPr>
       </p:sp>
       <p:sp>
@@ -6582,8 +6311,8 @@
         </p:nvSpPr>
         <p:spPr>
           <a:xfrm>
-            <a:off x="457200" y="2560320"/>
-            <a:ext cx="45720" cy="521208"/>
+            <a:off x="457200" y="2203704"/>
+            <a:ext cx="45720" cy="448056"/>
           </a:xfrm>
           <a:prstGeom prst="rect">
             <a:avLst/>
@@ -6602,8 +6331,8 @@
         </p:nvSpPr>
         <p:spPr>
           <a:xfrm>
-            <a:off x="685800" y="2560320"/>
-            <a:ext cx="7818120" cy="521208"/>
+            <a:off x="640080" y="2203704"/>
+            <a:ext cx="7863840" cy="448056"/>
           </a:xfrm>
           <a:prstGeom prst="rect">
             <a:avLst/>
@@ -6619,7 +6348,7 @@
               <a:buNone/>
             </a:pPr>
             <a:r>
-              <a:rPr lang="en-US" sz="1200" dirty="0">
+              <a:rPr lang="en-US" sz="1100" dirty="0">
                 <a:solidFill>
                   <a:srgbClr val="1A1A2E"/>
                 </a:solidFill>
@@ -6627,9 +6356,9 @@
                 <a:ea typeface="Calibri" pitchFamily="34" charset="-122"/>
                 <a:cs typeface="Calibri" pitchFamily="34" charset="-120"/>
               </a:rPr>
-              <a:t>Ajouter COMMENT sur chaque colonne</a:t>
-            </a:r>
-            <a:endParaRPr lang="en-US" sz="1200" dirty="0"/>
+              <a:t>4. Verifier chaque table avec SHOW CREATE TABLE</a:t>
+            </a:r>
+            <a:endParaRPr lang="en-US" sz="1100" dirty="0"/>
           </a:p>
         </p:txBody>
       </p:sp>
@@ -6641,8 +6370,8 @@
         </p:nvSpPr>
         <p:spPr>
           <a:xfrm>
-            <a:off x="457200" y="3108960"/>
-            <a:ext cx="8229600" cy="521208"/>
+            <a:off x="457200" y="2679192"/>
+            <a:ext cx="8229600" cy="448056"/>
           </a:xfrm>
           <a:prstGeom prst="rect">
             <a:avLst/>
@@ -6651,13 +6380,6 @@
             <a:srgbClr val="FFFFFF"/>
           </a:solidFill>
           <a:ln/>
-          <a:effectLst>
-            <a:outerShdw sx="100000" sy="100000" kx="0" ky="0" algn="bl" rotWithShape="0" blurRad="50800" dist="25400" dir="8100000">
-              <a:srgbClr val="000000">
-                <a:alpha val="12000"/>
-              </a:srgbClr>
-            </a:outerShdw>
-          </a:effectLst>
         </p:spPr>
       </p:sp>
       <p:sp>
@@ -6668,8 +6390,8 @@
         </p:nvSpPr>
         <p:spPr>
           <a:xfrm>
-            <a:off x="457200" y="3108960"/>
-            <a:ext cx="45720" cy="521208"/>
+            <a:off x="457200" y="2679192"/>
+            <a:ext cx="45720" cy="448056"/>
           </a:xfrm>
           <a:prstGeom prst="rect">
             <a:avLst/>
@@ -6688,8 +6410,8 @@
         </p:nvSpPr>
         <p:spPr>
           <a:xfrm>
-            <a:off x="685800" y="3108960"/>
-            <a:ext cx="7818120" cy="521208"/>
+            <a:off x="640080" y="2679192"/>
+            <a:ext cx="7863840" cy="448056"/>
           </a:xfrm>
           <a:prstGeom prst="rect">
             <a:avLst/>
@@ -6705,7 +6427,7 @@
               <a:buNone/>
             </a:pPr>
             <a:r>
-              <a:rPr lang="en-US" sz="1200" dirty="0">
+              <a:rPr lang="en-US" sz="1100" dirty="0">
                 <a:solidFill>
                   <a:srgbClr val="1A1A2E"/>
                 </a:solidFill>
@@ -6713,9 +6435,9 @@
                 <a:ea typeface="Calibri" pitchFamily="34" charset="-122"/>
                 <a:cs typeface="Calibri" pitchFamily="34" charset="-120"/>
               </a:rPr>
-              <a:t>Exécuter dans HeidiSQL et vérifier avec SHOW TABLES</a:t>
-            </a:r>
-            <a:endParaRPr lang="en-US" sz="1200" dirty="0"/>
+              <a:t>5. Sur GESCOM (bac a sable SQL) : explorer les 17 tables</a:t>
+            </a:r>
+            <a:endParaRPr lang="en-US" sz="1100" dirty="0"/>
           </a:p>
         </p:txBody>
       </p:sp>
@@ -6727,8 +6449,8 @@
         </p:nvSpPr>
         <p:spPr>
           <a:xfrm>
-            <a:off x="457200" y="3657600"/>
-            <a:ext cx="8229600" cy="521208"/>
+            <a:off x="457200" y="3154680"/>
+            <a:ext cx="8229600" cy="448056"/>
           </a:xfrm>
           <a:prstGeom prst="rect">
             <a:avLst/>
@@ -6737,13 +6459,6 @@
             <a:srgbClr val="E3F2FD"/>
           </a:solidFill>
           <a:ln/>
-          <a:effectLst>
-            <a:outerShdw sx="100000" sy="100000" kx="0" ky="0" algn="bl" rotWithShape="0" blurRad="50800" dist="25400" dir="8100000">
-              <a:srgbClr val="000000">
-                <a:alpha val="12000"/>
-              </a:srgbClr>
-            </a:outerShdw>
-          </a:effectLst>
         </p:spPr>
       </p:sp>
       <p:sp>
@@ -6754,8 +6469,8 @@
         </p:nvSpPr>
         <p:spPr>
           <a:xfrm>
-            <a:off x="457200" y="3657600"/>
-            <a:ext cx="45720" cy="521208"/>
+            <a:off x="457200" y="3154680"/>
+            <a:ext cx="45720" cy="448056"/>
           </a:xfrm>
           <a:prstGeom prst="rect">
             <a:avLst/>
@@ -6774,8 +6489,8 @@
         </p:nvSpPr>
         <p:spPr>
           <a:xfrm>
-            <a:off x="685800" y="3657600"/>
-            <a:ext cx="7818120" cy="521208"/>
+            <a:off x="640080" y="3154680"/>
+            <a:ext cx="7863840" cy="448056"/>
           </a:xfrm>
           <a:prstGeom prst="rect">
             <a:avLst/>
@@ -6791,7 +6506,7 @@
               <a:buNone/>
             </a:pPr>
             <a:r>
-              <a:rPr lang="en-US" sz="1200" dirty="0">
+              <a:rPr lang="en-US" sz="1100" dirty="0">
                 <a:solidFill>
                   <a:srgbClr val="1A1A2E"/>
                 </a:solidFill>
@@ -6799,9 +6514,9 @@
                 <a:ea typeface="Calibri" pitchFamily="34" charset="-122"/>
                 <a:cs typeface="Calibri" pitchFamily="34" charset="-120"/>
               </a:rPr>
-              <a:t>Vérifier chaque table avec SHOW CREATE TABLE nom;</a:t>
-            </a:r>
-            <a:endParaRPr lang="en-US" sz="1200" dirty="0"/>
+              <a:t>6. Exercice GESCOM #1 : SELECT NOART, DESART, NOFAM FROM article;</a:t>
+            </a:r>
+            <a:endParaRPr lang="en-US" sz="1100" dirty="0"/>
           </a:p>
         </p:txBody>
       </p:sp>
@@ -6813,8 +6528,8 @@
         </p:nvSpPr>
         <p:spPr>
           <a:xfrm>
-            <a:off x="457200" y="4206240"/>
-            <a:ext cx="8229600" cy="521208"/>
+            <a:off x="457200" y="3630168"/>
+            <a:ext cx="8229600" cy="448056"/>
           </a:xfrm>
           <a:prstGeom prst="rect">
             <a:avLst/>
@@ -6823,13 +6538,6 @@
             <a:srgbClr val="FFFFFF"/>
           </a:solidFill>
           <a:ln/>
-          <a:effectLst>
-            <a:outerShdw sx="100000" sy="100000" kx="0" ky="0" algn="bl" rotWithShape="0" blurRad="50800" dist="25400" dir="8100000">
-              <a:srgbClr val="000000">
-                <a:alpha val="12000"/>
-              </a:srgbClr>
-            </a:outerShdw>
-          </a:effectLst>
         </p:spPr>
       </p:sp>
       <p:sp>
@@ -6840,8 +6548,8 @@
         </p:nvSpPr>
         <p:spPr>
           <a:xfrm>
-            <a:off x="457200" y="4206240"/>
-            <a:ext cx="45720" cy="521208"/>
+            <a:off x="457200" y="3630168"/>
+            <a:ext cx="45720" cy="448056"/>
           </a:xfrm>
           <a:prstGeom prst="rect">
             <a:avLst/>
@@ -6860,8 +6568,8 @@
         </p:nvSpPr>
         <p:spPr>
           <a:xfrm>
-            <a:off x="685800" y="4206240"/>
-            <a:ext cx="7818120" cy="521208"/>
+            <a:off x="640080" y="3630168"/>
+            <a:ext cx="7863840" cy="448056"/>
           </a:xfrm>
           <a:prstGeom prst="rect">
             <a:avLst/>
@@ -6877,7 +6585,7 @@
               <a:buNone/>
             </a:pPr>
             <a:r>
-              <a:rPr lang="en-US" sz="1200" dirty="0">
+              <a:rPr lang="en-US" sz="1100" dirty="0">
                 <a:solidFill>
                   <a:srgbClr val="1A1A2E"/>
                 </a:solidFill>
@@ -6885,9 +6593,9 @@
                 <a:ea typeface="Calibri" pitchFamily="34" charset="-122"/>
                 <a:cs typeface="Calibri" pitchFamily="34" charset="-120"/>
               </a:rPr>
-              <a:t>DÉFI : écrire le script de destruction (DROP) en ordre inverse</a:t>
-            </a:r>
-            <a:endParaRPr lang="en-US" sz="1200" dirty="0"/>
+              <a:t>DEFI : ecrire le script DROP en ordre inverse</a:t>
+            </a:r>
+            <a:endParaRPr lang="en-US" sz="1100" dirty="0"/>
           </a:p>
         </p:txBody>
       </p:sp>
@@ -6931,8 +6639,8 @@
         </p:nvSpPr>
         <p:spPr>
           <a:xfrm>
-            <a:off x="3840480" y="457200"/>
-            <a:ext cx="1463040" cy="1097280"/>
+            <a:off x="457200" y="1828800"/>
+            <a:ext cx="8229600" cy="548640"/>
           </a:xfrm>
           <a:prstGeom prst="rect">
             <a:avLst/>
@@ -6948,43 +6656,7 @@
               <a:buNone/>
             </a:pPr>
             <a:r>
-              <a:rPr lang="en-US" sz="6000" dirty="0">
-                <a:solidFill>
-                  <a:srgbClr val="000000"/>
-                </a:solidFill>
-              </a:rPr>
-              <a:t>🎮</a:t>
-            </a:r>
-            <a:endParaRPr lang="en-US" sz="6000" dirty="0"/>
-          </a:p>
-        </p:txBody>
-      </p:sp>
-      <p:sp>
-        <p:nvSpPr>
-          <p:cNvPr id="3" name="Text 1"/>
-          <p:cNvSpPr/>
-          <p:nvPr/>
-        </p:nvSpPr>
-        <p:spPr>
-          <a:xfrm>
-            <a:off x="457200" y="1645920"/>
-            <a:ext cx="8229600" cy="548640"/>
-          </a:xfrm>
-          <a:prstGeom prst="rect">
-            <a:avLst/>
-          </a:prstGeom>
-          <a:noFill/>
-          <a:ln/>
-        </p:spPr>
-        <p:txBody>
-          <a:bodyPr wrap="square" lIns="0" tIns="0" rIns="0" bIns="0" rtlCol="0" anchor="ctr"/>
-          <a:lstStyle/>
-          <a:p>
-            <a:pPr algn="ctr" indent="0" marL="0">
-              <a:buNone/>
-            </a:pPr>
-            <a:r>
-              <a:rPr lang="en-US" sz="2600" b="1" dirty="0">
+              <a:rPr lang="en-US" sz="2200" b="1" dirty="0">
                 <a:solidFill>
                   <a:srgbClr val="FFFFFF"/>
                 </a:solidFill>
@@ -6994,20 +6666,20 @@
               </a:rPr>
               <a:t>Mini-jeu : L'Architecte SQL</a:t>
             </a:r>
-            <a:endParaRPr lang="en-US" sz="2600" dirty="0"/>
-          </a:p>
-        </p:txBody>
-      </p:sp>
-      <p:sp>
-        <p:nvSpPr>
-          <p:cNvPr id="4" name="Text 2"/>
-          <p:cNvSpPr/>
-          <p:nvPr/>
-        </p:nvSpPr>
-        <p:spPr>
-          <a:xfrm>
-            <a:off x="1371600" y="2286000"/>
-            <a:ext cx="6400800" cy="731520"/>
+            <a:endParaRPr lang="en-US" sz="2200" dirty="0"/>
+          </a:p>
+        </p:txBody>
+      </p:sp>
+      <p:sp>
+        <p:nvSpPr>
+          <p:cNvPr id="3" name="Text 1"/>
+          <p:cNvSpPr/>
+          <p:nvPr/>
+        </p:nvSpPr>
+        <p:spPr>
+          <a:xfrm>
+            <a:off x="1371600" y="2468880"/>
+            <a:ext cx="6400800" cy="457200"/>
           </a:xfrm>
           <a:prstGeom prst="rect">
             <a:avLst/>
@@ -7023,7 +6695,7 @@
               <a:buNone/>
             </a:pPr>
             <a:r>
-              <a:rPr lang="en-US" sz="1400" dirty="0">
+              <a:rPr lang="en-US" sz="1300" dirty="0">
                 <a:solidFill>
                   <a:srgbClr val="CCCCCC"/>
                 </a:solidFill>
@@ -7033,66 +6705,7 @@
               </a:rPr>
               <a:t>Construisez la BDD dans le bon ordre !</a:t>
             </a:r>
-            <a:endParaRPr lang="en-US" sz="1400" dirty="0"/>
-          </a:p>
-        </p:txBody>
-      </p:sp>
-      <p:sp>
-        <p:nvSpPr>
-          <p:cNvPr id="5" name="Shape 3"/>
-          <p:cNvSpPr/>
-          <p:nvPr/>
-        </p:nvSpPr>
-        <p:spPr>
-          <a:xfrm>
-            <a:off x="2286000" y="3291840"/>
-            <a:ext cx="4572000" cy="548640"/>
-          </a:xfrm>
-          <a:prstGeom prst="rect">
-            <a:avLst/>
-          </a:prstGeom>
-          <a:solidFill>
-            <a:srgbClr val="FF6F00"/>
-          </a:solidFill>
-          <a:ln/>
-        </p:spPr>
-      </p:sp>
-      <p:sp>
-        <p:nvSpPr>
-          <p:cNvPr id="6" name="Text 4"/>
-          <p:cNvSpPr/>
-          <p:nvPr/>
-        </p:nvSpPr>
-        <p:spPr>
-          <a:xfrm>
-            <a:off x="2286000" y="3291840"/>
-            <a:ext cx="4572000" cy="548640"/>
-          </a:xfrm>
-          <a:prstGeom prst="rect">
-            <a:avLst/>
-          </a:prstGeom>
-          <a:noFill/>
-          <a:ln/>
-        </p:spPr>
-        <p:txBody>
-          <a:bodyPr wrap="square" lIns="0" tIns="0" rIns="0" bIns="0" rtlCol="0" anchor="ctr"/>
-          <a:lstStyle/>
-          <a:p>
-            <a:pPr algn="ctr" indent="0" marL="0">
-              <a:buNone/>
-            </a:pPr>
-            <a:r>
-              <a:rPr lang="en-US" sz="1800" b="1" dirty="0">
-                <a:solidFill>
-                  <a:srgbClr val="FFFFFF"/>
-                </a:solidFill>
-                <a:latin typeface="Trebuchet MS" pitchFamily="34" charset="0"/>
-                <a:ea typeface="Trebuchet MS" pitchFamily="34" charset="-122"/>
-                <a:cs typeface="Trebuchet MS" pitchFamily="34" charset="-120"/>
-              </a:rPr>
-              <a:t>▶  Lancer le jeu</a:t>
-            </a:r>
-            <a:endParaRPr lang="en-US" sz="1800" dirty="0"/>
+            <a:endParaRPr lang="en-US" sz="1300" dirty="0"/>
           </a:p>
         </p:txBody>
       </p:sp>
@@ -7137,7 +6750,7 @@
         <p:spPr>
           <a:xfrm>
             <a:off x="457200" y="137160"/>
-            <a:ext cx="5486400" cy="411480"/>
+            <a:ext cx="5486400" cy="365760"/>
           </a:xfrm>
           <a:prstGeom prst="rect">
             <a:avLst/>
@@ -7153,7 +6766,7 @@
               <a:buNone/>
             </a:pPr>
             <a:r>
-              <a:rPr lang="en-US" sz="1800" b="1" dirty="0">
+              <a:rPr lang="en-US" sz="1600" b="1" dirty="0">
                 <a:solidFill>
                   <a:srgbClr val="0D47A1"/>
                 </a:solidFill>
@@ -7161,9 +6774,9 @@
                 <a:ea typeface="Trebuchet MS" pitchFamily="34" charset="-122"/>
                 <a:cs typeface="Trebuchet MS" pitchFamily="34" charset="-120"/>
               </a:rPr>
-              <a:t>📋 Mémo Module 9</a:t>
-            </a:r>
-            <a:endParaRPr lang="en-US" sz="1800" dirty="0"/>
+              <a:t>Memo Module 9</a:t>
+            </a:r>
+            <a:endParaRPr lang="en-US" sz="1600" dirty="0"/>
           </a:p>
         </p:txBody>
       </p:sp>
@@ -7175,14 +6788,14 @@
         </p:nvSpPr>
         <p:spPr>
           <a:xfrm>
-            <a:off x="457200" y="548640"/>
-            <a:ext cx="8229600" cy="274320"/>
-          </a:xfrm>
-          <a:prstGeom prst="rect">
-            <a:avLst/>
-          </a:prstGeom>
-          <a:solidFill>
-            <a:srgbClr val="FFF3E0"/>
+            <a:off x="457200" y="594360"/>
+            <a:ext cx="2286000" cy="411480"/>
+          </a:xfrm>
+          <a:prstGeom prst="rect">
+            <a:avLst/>
+          </a:prstGeom>
+          <a:solidFill>
+            <a:srgbClr val="E3F2FD"/>
           </a:solidFill>
           <a:ln/>
         </p:spPr>
@@ -7195,8 +6808,8 @@
         </p:nvSpPr>
         <p:spPr>
           <a:xfrm>
-            <a:off x="640080" y="548640"/>
-            <a:ext cx="7772400" cy="274320"/>
+            <a:off x="548640" y="594360"/>
+            <a:ext cx="2103120" cy="411480"/>
           </a:xfrm>
           <a:prstGeom prst="rect">
             <a:avLst/>
@@ -7214,13 +6827,72 @@
             <a:r>
               <a:rPr lang="en-US" sz="900" b="1" dirty="0">
                 <a:solidFill>
-                  <a:srgbClr val="E65100"/>
+                  <a:srgbClr val="0D47A1"/>
+                </a:solidFill>
+                <a:latin typeface="Trebuchet MS" pitchFamily="34" charset="0"/>
+                <a:ea typeface="Trebuchet MS" pitchFamily="34" charset="-122"/>
+                <a:cs typeface="Trebuchet MS" pitchFamily="34" charset="-120"/>
+              </a:rPr>
+              <a:t>DDL</a:t>
+            </a:r>
+            <a:endParaRPr lang="en-US" sz="900" dirty="0"/>
+          </a:p>
+        </p:txBody>
+      </p:sp>
+      <p:sp>
+        <p:nvSpPr>
+          <p:cNvPr id="5" name="Shape 3"/>
+          <p:cNvSpPr/>
+          <p:nvPr/>
+        </p:nvSpPr>
+        <p:spPr>
+          <a:xfrm>
+            <a:off x="2743200" y="594360"/>
+            <a:ext cx="5943600" cy="411480"/>
+          </a:xfrm>
+          <a:prstGeom prst="rect">
+            <a:avLst/>
+          </a:prstGeom>
+          <a:solidFill>
+            <a:srgbClr val="E3F2FD"/>
+          </a:solidFill>
+          <a:ln/>
+        </p:spPr>
+      </p:sp>
+      <p:sp>
+        <p:nvSpPr>
+          <p:cNvPr id="6" name="Text 4"/>
+          <p:cNvSpPr/>
+          <p:nvPr/>
+        </p:nvSpPr>
+        <p:spPr>
+          <a:xfrm>
+            <a:off x="2834640" y="594360"/>
+            <a:ext cx="5760720" cy="411480"/>
+          </a:xfrm>
+          <a:prstGeom prst="rect">
+            <a:avLst/>
+          </a:prstGeom>
+          <a:noFill/>
+          <a:ln/>
+        </p:spPr>
+        <p:txBody>
+          <a:bodyPr wrap="square" lIns="0" tIns="0" rIns="0" bIns="0" rtlCol="0" anchor="ctr"/>
+          <a:lstStyle/>
+          <a:p>
+            <a:pPr indent="0" marL="0">
+              <a:buNone/>
+            </a:pPr>
+            <a:r>
+              <a:rPr lang="en-US" sz="900" dirty="0">
+                <a:solidFill>
+                  <a:srgbClr val="333333"/>
                 </a:solidFill>
                 <a:latin typeface="Calibri" pitchFamily="34" charset="0"/>
                 <a:ea typeface="Calibri" pitchFamily="34" charset="-122"/>
                 <a:cs typeface="Calibri" pitchFamily="34" charset="-120"/>
               </a:rPr>
-              <a:t>🔒 Déblocable après complétion</a:t>
+              <a:t>CREATE, ALTER, DROP, SHOW — modifie la STRUCTURE</a:t>
             </a:r>
             <a:endParaRPr lang="en-US" sz="900" dirty="0"/>
           </a:p>
@@ -7228,34 +6900,34 @@
       </p:sp>
       <p:sp>
         <p:nvSpPr>
-          <p:cNvPr id="5" name="Shape 3"/>
-          <p:cNvSpPr/>
-          <p:nvPr/>
-        </p:nvSpPr>
-        <p:spPr>
-          <a:xfrm>
-            <a:off x="457200" y="960120"/>
-            <a:ext cx="2286000" cy="475488"/>
-          </a:xfrm>
-          <a:prstGeom prst="rect">
-            <a:avLst/>
-          </a:prstGeom>
-          <a:solidFill>
-            <a:srgbClr val="E3F2FD"/>
-          </a:solidFill>
-          <a:ln/>
-        </p:spPr>
-      </p:sp>
-      <p:sp>
-        <p:nvSpPr>
-          <p:cNvPr id="6" name="Text 4"/>
-          <p:cNvSpPr/>
-          <p:nvPr/>
-        </p:nvSpPr>
-        <p:spPr>
-          <a:xfrm>
-            <a:off x="548640" y="960120"/>
-            <a:ext cx="2103120" cy="475488"/>
+          <p:cNvPr id="7" name="Shape 5"/>
+          <p:cNvSpPr/>
+          <p:nvPr/>
+        </p:nvSpPr>
+        <p:spPr>
+          <a:xfrm>
+            <a:off x="457200" y="1033272"/>
+            <a:ext cx="2286000" cy="411480"/>
+          </a:xfrm>
+          <a:prstGeom prst="rect">
+            <a:avLst/>
+          </a:prstGeom>
+          <a:solidFill>
+            <a:srgbClr val="F0F0F0"/>
+          </a:solidFill>
+          <a:ln/>
+        </p:spPr>
+      </p:sp>
+      <p:sp>
+        <p:nvSpPr>
+          <p:cNvPr id="8" name="Text 6"/>
+          <p:cNvSpPr/>
+          <p:nvPr/>
+        </p:nvSpPr>
+        <p:spPr>
+          <a:xfrm>
+            <a:off x="548640" y="1033272"/>
+            <a:ext cx="2103120" cy="411480"/>
           </a:xfrm>
           <a:prstGeom prst="rect">
             <a:avLst/>
@@ -7279,7 +6951,7 @@
                 <a:ea typeface="Trebuchet MS" pitchFamily="34" charset="-122"/>
                 <a:cs typeface="Trebuchet MS" pitchFamily="34" charset="-120"/>
               </a:rPr>
-              <a:t>DDL</a:t>
+              <a:t>CREATE TABLE</a:t>
             </a:r>
             <a:endParaRPr lang="en-US" sz="900" dirty="0"/>
           </a:p>
@@ -7287,34 +6959,34 @@
       </p:sp>
       <p:sp>
         <p:nvSpPr>
-          <p:cNvPr id="7" name="Shape 5"/>
-          <p:cNvSpPr/>
-          <p:nvPr/>
-        </p:nvSpPr>
-        <p:spPr>
-          <a:xfrm>
-            <a:off x="2743200" y="960120"/>
-            <a:ext cx="5943600" cy="475488"/>
-          </a:xfrm>
-          <a:prstGeom prst="rect">
-            <a:avLst/>
-          </a:prstGeom>
-          <a:solidFill>
-            <a:srgbClr val="E3F2FD"/>
-          </a:solidFill>
-          <a:ln/>
-        </p:spPr>
-      </p:sp>
-      <p:sp>
-        <p:nvSpPr>
-          <p:cNvPr id="8" name="Text 6"/>
-          <p:cNvSpPr/>
-          <p:nvPr/>
-        </p:nvSpPr>
-        <p:spPr>
-          <a:xfrm>
-            <a:off x="2834640" y="960120"/>
-            <a:ext cx="5760720" cy="475488"/>
+          <p:cNvPr id="9" name="Shape 7"/>
+          <p:cNvSpPr/>
+          <p:nvPr/>
+        </p:nvSpPr>
+        <p:spPr>
+          <a:xfrm>
+            <a:off x="2743200" y="1033272"/>
+            <a:ext cx="5943600" cy="411480"/>
+          </a:xfrm>
+          <a:prstGeom prst="rect">
+            <a:avLst/>
+          </a:prstGeom>
+          <a:solidFill>
+            <a:srgbClr val="F0F0F0"/>
+          </a:solidFill>
+          <a:ln/>
+        </p:spPr>
+      </p:sp>
+      <p:sp>
+        <p:nvSpPr>
+          <p:cNvPr id="10" name="Text 8"/>
+          <p:cNvSpPr/>
+          <p:nvPr/>
+        </p:nvSpPr>
+        <p:spPr>
+          <a:xfrm>
+            <a:off x="2834640" y="1033272"/>
+            <a:ext cx="5760720" cy="411480"/>
           </a:xfrm>
           <a:prstGeom prst="rect">
             <a:avLst/>
@@ -7338,7 +7010,7 @@
                 <a:ea typeface="Calibri" pitchFamily="34" charset="-122"/>
                 <a:cs typeface="Calibri" pitchFamily="34" charset="-120"/>
               </a:rPr>
-              <a:t>CREATE, ALTER, DROP, SHOW — modifie la STRUCTURE</a:t>
+              <a:t>Colonnes avec type + contraintes</a:t>
             </a:r>
             <a:endParaRPr lang="en-US" sz="900" dirty="0"/>
           </a:p>
@@ -7346,34 +7018,34 @@
       </p:sp>
       <p:sp>
         <p:nvSpPr>
-          <p:cNvPr id="9" name="Shape 7"/>
-          <p:cNvSpPr/>
-          <p:nvPr/>
-        </p:nvSpPr>
-        <p:spPr>
-          <a:xfrm>
-            <a:off x="457200" y="1463040"/>
-            <a:ext cx="2286000" cy="475488"/>
-          </a:xfrm>
-          <a:prstGeom prst="rect">
-            <a:avLst/>
-          </a:prstGeom>
-          <a:solidFill>
-            <a:srgbClr val="F0F0F0"/>
-          </a:solidFill>
-          <a:ln/>
-        </p:spPr>
-      </p:sp>
-      <p:sp>
-        <p:nvSpPr>
-          <p:cNvPr id="10" name="Text 8"/>
-          <p:cNvSpPr/>
-          <p:nvPr/>
-        </p:nvSpPr>
-        <p:spPr>
-          <a:xfrm>
-            <a:off x="548640" y="1463040"/>
-            <a:ext cx="2103120" cy="475488"/>
+          <p:cNvPr id="11" name="Shape 9"/>
+          <p:cNvSpPr/>
+          <p:nvPr/>
+        </p:nvSpPr>
+        <p:spPr>
+          <a:xfrm>
+            <a:off x="457200" y="1472184"/>
+            <a:ext cx="2286000" cy="411480"/>
+          </a:xfrm>
+          <a:prstGeom prst="rect">
+            <a:avLst/>
+          </a:prstGeom>
+          <a:solidFill>
+            <a:srgbClr val="E3F2FD"/>
+          </a:solidFill>
+          <a:ln/>
+        </p:spPr>
+      </p:sp>
+      <p:sp>
+        <p:nvSpPr>
+          <p:cNvPr id="12" name="Text 10"/>
+          <p:cNvSpPr/>
+          <p:nvPr/>
+        </p:nvSpPr>
+        <p:spPr>
+          <a:xfrm>
+            <a:off x="548640" y="1472184"/>
+            <a:ext cx="2103120" cy="411480"/>
           </a:xfrm>
           <a:prstGeom prst="rect">
             <a:avLst/>
@@ -7397,7 +7069,7 @@
                 <a:ea typeface="Trebuchet MS" pitchFamily="34" charset="-122"/>
                 <a:cs typeface="Trebuchet MS" pitchFamily="34" charset="-120"/>
               </a:rPr>
-              <a:t>CREATE TABLE</a:t>
+              <a:t>Ordre FK</a:t>
             </a:r>
             <a:endParaRPr lang="en-US" sz="900" dirty="0"/>
           </a:p>
@@ -7405,34 +7077,34 @@
       </p:sp>
       <p:sp>
         <p:nvSpPr>
-          <p:cNvPr id="11" name="Shape 9"/>
-          <p:cNvSpPr/>
-          <p:nvPr/>
-        </p:nvSpPr>
-        <p:spPr>
-          <a:xfrm>
-            <a:off x="2743200" y="1463040"/>
-            <a:ext cx="5943600" cy="475488"/>
-          </a:xfrm>
-          <a:prstGeom prst="rect">
-            <a:avLst/>
-          </a:prstGeom>
-          <a:solidFill>
-            <a:srgbClr val="F0F0F0"/>
-          </a:solidFill>
-          <a:ln/>
-        </p:spPr>
-      </p:sp>
-      <p:sp>
-        <p:nvSpPr>
-          <p:cNvPr id="12" name="Text 10"/>
-          <p:cNvSpPr/>
-          <p:nvPr/>
-        </p:nvSpPr>
-        <p:spPr>
-          <a:xfrm>
-            <a:off x="2834640" y="1463040"/>
-            <a:ext cx="5760720" cy="475488"/>
+          <p:cNvPr id="13" name="Shape 11"/>
+          <p:cNvSpPr/>
+          <p:nvPr/>
+        </p:nvSpPr>
+        <p:spPr>
+          <a:xfrm>
+            <a:off x="2743200" y="1472184"/>
+            <a:ext cx="5943600" cy="411480"/>
+          </a:xfrm>
+          <a:prstGeom prst="rect">
+            <a:avLst/>
+          </a:prstGeom>
+          <a:solidFill>
+            <a:srgbClr val="E3F2FD"/>
+          </a:solidFill>
+          <a:ln/>
+        </p:spPr>
+      </p:sp>
+      <p:sp>
+        <p:nvSpPr>
+          <p:cNvPr id="14" name="Text 12"/>
+          <p:cNvSpPr/>
+          <p:nvPr/>
+        </p:nvSpPr>
+        <p:spPr>
+          <a:xfrm>
+            <a:off x="2834640" y="1472184"/>
+            <a:ext cx="5760720" cy="411480"/>
           </a:xfrm>
           <a:prstGeom prst="rect">
             <a:avLst/>
@@ -7456,7 +7128,7 @@
                 <a:ea typeface="Calibri" pitchFamily="34" charset="-122"/>
                 <a:cs typeface="Calibri" pitchFamily="34" charset="-120"/>
               </a:rPr>
-              <a:t>Définir colonnes avec type + contraintes</a:t>
+              <a:t>Table referencee AVANT table qui reference</a:t>
             </a:r>
             <a:endParaRPr lang="en-US" sz="900" dirty="0"/>
           </a:p>
@@ -7464,34 +7136,34 @@
       </p:sp>
       <p:sp>
         <p:nvSpPr>
-          <p:cNvPr id="13" name="Shape 11"/>
-          <p:cNvSpPr/>
-          <p:nvPr/>
-        </p:nvSpPr>
-        <p:spPr>
-          <a:xfrm>
-            <a:off x="457200" y="1965960"/>
-            <a:ext cx="2286000" cy="475488"/>
-          </a:xfrm>
-          <a:prstGeom prst="rect">
-            <a:avLst/>
-          </a:prstGeom>
-          <a:solidFill>
-            <a:srgbClr val="E3F2FD"/>
-          </a:solidFill>
-          <a:ln/>
-        </p:spPr>
-      </p:sp>
-      <p:sp>
-        <p:nvSpPr>
-          <p:cNvPr id="14" name="Text 12"/>
-          <p:cNvSpPr/>
-          <p:nvPr/>
-        </p:nvSpPr>
-        <p:spPr>
-          <a:xfrm>
-            <a:off x="548640" y="1965960"/>
-            <a:ext cx="2103120" cy="475488"/>
+          <p:cNvPr id="15" name="Shape 13"/>
+          <p:cNvSpPr/>
+          <p:nvPr/>
+        </p:nvSpPr>
+        <p:spPr>
+          <a:xfrm>
+            <a:off x="457200" y="1911096"/>
+            <a:ext cx="2286000" cy="411480"/>
+          </a:xfrm>
+          <a:prstGeom prst="rect">
+            <a:avLst/>
+          </a:prstGeom>
+          <a:solidFill>
+            <a:srgbClr val="F0F0F0"/>
+          </a:solidFill>
+          <a:ln/>
+        </p:spPr>
+      </p:sp>
+      <p:sp>
+        <p:nvSpPr>
+          <p:cNvPr id="16" name="Text 14"/>
+          <p:cNvSpPr/>
+          <p:nvPr/>
+        </p:nvSpPr>
+        <p:spPr>
+          <a:xfrm>
+            <a:off x="548640" y="1911096"/>
+            <a:ext cx="2103120" cy="411480"/>
           </a:xfrm>
           <a:prstGeom prst="rect">
             <a:avLst/>
@@ -7515,7 +7187,7 @@
                 <a:ea typeface="Trebuchet MS" pitchFamily="34" charset="-122"/>
                 <a:cs typeface="Trebuchet MS" pitchFamily="34" charset="-120"/>
               </a:rPr>
-              <a:t>Ordre FK</a:t>
+              <a:t>DROP IF EXISTS</a:t>
             </a:r>
             <a:endParaRPr lang="en-US" sz="900" dirty="0"/>
           </a:p>
@@ -7523,34 +7195,34 @@
       </p:sp>
       <p:sp>
         <p:nvSpPr>
-          <p:cNvPr id="15" name="Shape 13"/>
-          <p:cNvSpPr/>
-          <p:nvPr/>
-        </p:nvSpPr>
-        <p:spPr>
-          <a:xfrm>
-            <a:off x="2743200" y="1965960"/>
-            <a:ext cx="5943600" cy="475488"/>
-          </a:xfrm>
-          <a:prstGeom prst="rect">
-            <a:avLst/>
-          </a:prstGeom>
-          <a:solidFill>
-            <a:srgbClr val="E3F2FD"/>
-          </a:solidFill>
-          <a:ln/>
-        </p:spPr>
-      </p:sp>
-      <p:sp>
-        <p:nvSpPr>
-          <p:cNvPr id="16" name="Text 14"/>
-          <p:cNvSpPr/>
-          <p:nvPr/>
-        </p:nvSpPr>
-        <p:spPr>
-          <a:xfrm>
-            <a:off x="2834640" y="1965960"/>
-            <a:ext cx="5760720" cy="475488"/>
+          <p:cNvPr id="17" name="Shape 15"/>
+          <p:cNvSpPr/>
+          <p:nvPr/>
+        </p:nvSpPr>
+        <p:spPr>
+          <a:xfrm>
+            <a:off x="2743200" y="1911096"/>
+            <a:ext cx="5943600" cy="411480"/>
+          </a:xfrm>
+          <a:prstGeom prst="rect">
+            <a:avLst/>
+          </a:prstGeom>
+          <a:solidFill>
+            <a:srgbClr val="F0F0F0"/>
+          </a:solidFill>
+          <a:ln/>
+        </p:spPr>
+      </p:sp>
+      <p:sp>
+        <p:nvSpPr>
+          <p:cNvPr id="18" name="Text 16"/>
+          <p:cNvSpPr/>
+          <p:nvPr/>
+        </p:nvSpPr>
+        <p:spPr>
+          <a:xfrm>
+            <a:off x="2834640" y="1911096"/>
+            <a:ext cx="5760720" cy="411480"/>
           </a:xfrm>
           <a:prstGeom prst="rect">
             <a:avLst/>
@@ -7574,7 +7246,7 @@
                 <a:ea typeface="Calibri" pitchFamily="34" charset="-122"/>
                 <a:cs typeface="Calibri" pitchFamily="34" charset="-120"/>
               </a:rPr>
-              <a:t>Table référencée AVANT table qui référence</a:t>
+              <a:t>Suppression sans erreur si absente</a:t>
             </a:r>
             <a:endParaRPr lang="en-US" sz="900" dirty="0"/>
           </a:p>
@@ -7582,34 +7254,34 @@
       </p:sp>
       <p:sp>
         <p:nvSpPr>
-          <p:cNvPr id="17" name="Shape 15"/>
-          <p:cNvSpPr/>
-          <p:nvPr/>
-        </p:nvSpPr>
-        <p:spPr>
-          <a:xfrm>
-            <a:off x="457200" y="2468880"/>
-            <a:ext cx="2286000" cy="475488"/>
-          </a:xfrm>
-          <a:prstGeom prst="rect">
-            <a:avLst/>
-          </a:prstGeom>
-          <a:solidFill>
-            <a:srgbClr val="F0F0F0"/>
-          </a:solidFill>
-          <a:ln/>
-        </p:spPr>
-      </p:sp>
-      <p:sp>
-        <p:nvSpPr>
-          <p:cNvPr id="18" name="Text 16"/>
-          <p:cNvSpPr/>
-          <p:nvPr/>
-        </p:nvSpPr>
-        <p:spPr>
-          <a:xfrm>
-            <a:off x="548640" y="2468880"/>
-            <a:ext cx="2103120" cy="475488"/>
+          <p:cNvPr id="19" name="Shape 17"/>
+          <p:cNvSpPr/>
+          <p:nvPr/>
+        </p:nvSpPr>
+        <p:spPr>
+          <a:xfrm>
+            <a:off x="457200" y="2350008"/>
+            <a:ext cx="2286000" cy="411480"/>
+          </a:xfrm>
+          <a:prstGeom prst="rect">
+            <a:avLst/>
+          </a:prstGeom>
+          <a:solidFill>
+            <a:srgbClr val="E3F2FD"/>
+          </a:solidFill>
+          <a:ln/>
+        </p:spPr>
+      </p:sp>
+      <p:sp>
+        <p:nvSpPr>
+          <p:cNvPr id="20" name="Text 18"/>
+          <p:cNvSpPr/>
+          <p:nvPr/>
+        </p:nvSpPr>
+        <p:spPr>
+          <a:xfrm>
+            <a:off x="548640" y="2350008"/>
+            <a:ext cx="2103120" cy="411480"/>
           </a:xfrm>
           <a:prstGeom prst="rect">
             <a:avLst/>
@@ -7633,7 +7305,7 @@
                 <a:ea typeface="Trebuchet MS" pitchFamily="34" charset="-122"/>
                 <a:cs typeface="Trebuchet MS" pitchFamily="34" charset="-120"/>
               </a:rPr>
-              <a:t>DROP IF EXISTS</a:t>
+              <a:t>SHOW CREATE TABLE</a:t>
             </a:r>
             <a:endParaRPr lang="en-US" sz="900" dirty="0"/>
           </a:p>
@@ -7641,34 +7313,34 @@
       </p:sp>
       <p:sp>
         <p:nvSpPr>
-          <p:cNvPr id="19" name="Shape 17"/>
-          <p:cNvSpPr/>
-          <p:nvPr/>
-        </p:nvSpPr>
-        <p:spPr>
-          <a:xfrm>
-            <a:off x="2743200" y="2468880"/>
-            <a:ext cx="5943600" cy="475488"/>
-          </a:xfrm>
-          <a:prstGeom prst="rect">
-            <a:avLst/>
-          </a:prstGeom>
-          <a:solidFill>
-            <a:srgbClr val="F0F0F0"/>
-          </a:solidFill>
-          <a:ln/>
-        </p:spPr>
-      </p:sp>
-      <p:sp>
-        <p:nvSpPr>
-          <p:cNvPr id="20" name="Text 18"/>
-          <p:cNvSpPr/>
-          <p:nvPr/>
-        </p:nvSpPr>
-        <p:spPr>
-          <a:xfrm>
-            <a:off x="2834640" y="2468880"/>
-            <a:ext cx="5760720" cy="475488"/>
+          <p:cNvPr id="21" name="Shape 19"/>
+          <p:cNvSpPr/>
+          <p:nvPr/>
+        </p:nvSpPr>
+        <p:spPr>
+          <a:xfrm>
+            <a:off x="2743200" y="2350008"/>
+            <a:ext cx="5943600" cy="411480"/>
+          </a:xfrm>
+          <a:prstGeom prst="rect">
+            <a:avLst/>
+          </a:prstGeom>
+          <a:solidFill>
+            <a:srgbClr val="E3F2FD"/>
+          </a:solidFill>
+          <a:ln/>
+        </p:spPr>
+      </p:sp>
+      <p:sp>
+        <p:nvSpPr>
+          <p:cNvPr id="22" name="Text 20"/>
+          <p:cNvSpPr/>
+          <p:nvPr/>
+        </p:nvSpPr>
+        <p:spPr>
+          <a:xfrm>
+            <a:off x="2834640" y="2350008"/>
+            <a:ext cx="5760720" cy="411480"/>
           </a:xfrm>
           <a:prstGeom prst="rect">
             <a:avLst/>
@@ -7692,7 +7364,7 @@
                 <a:ea typeface="Calibri" pitchFamily="34" charset="-122"/>
                 <a:cs typeface="Calibri" pitchFamily="34" charset="-120"/>
               </a:rPr>
-              <a:t>Suppression sans erreur si table absente</a:t>
+              <a:t>Voir la structure complete</a:t>
             </a:r>
             <a:endParaRPr lang="en-US" sz="900" dirty="0"/>
           </a:p>
@@ -7700,34 +7372,34 @@
       </p:sp>
       <p:sp>
         <p:nvSpPr>
-          <p:cNvPr id="21" name="Shape 19"/>
-          <p:cNvSpPr/>
-          <p:nvPr/>
-        </p:nvSpPr>
-        <p:spPr>
-          <a:xfrm>
-            <a:off x="457200" y="2971800"/>
-            <a:ext cx="2286000" cy="475488"/>
-          </a:xfrm>
-          <a:prstGeom prst="rect">
-            <a:avLst/>
-          </a:prstGeom>
-          <a:solidFill>
-            <a:srgbClr val="E3F2FD"/>
-          </a:solidFill>
-          <a:ln/>
-        </p:spPr>
-      </p:sp>
-      <p:sp>
-        <p:nvSpPr>
-          <p:cNvPr id="22" name="Text 20"/>
-          <p:cNvSpPr/>
-          <p:nvPr/>
-        </p:nvSpPr>
-        <p:spPr>
-          <a:xfrm>
-            <a:off x="548640" y="2971800"/>
-            <a:ext cx="2103120" cy="475488"/>
+          <p:cNvPr id="23" name="Shape 21"/>
+          <p:cNvSpPr/>
+          <p:nvPr/>
+        </p:nvSpPr>
+        <p:spPr>
+          <a:xfrm>
+            <a:off x="457200" y="2788920"/>
+            <a:ext cx="2286000" cy="411480"/>
+          </a:xfrm>
+          <a:prstGeom prst="rect">
+            <a:avLst/>
+          </a:prstGeom>
+          <a:solidFill>
+            <a:srgbClr val="F0F0F0"/>
+          </a:solidFill>
+          <a:ln/>
+        </p:spPr>
+      </p:sp>
+      <p:sp>
+        <p:nvSpPr>
+          <p:cNvPr id="24" name="Text 22"/>
+          <p:cNvSpPr/>
+          <p:nvPr/>
+        </p:nvSpPr>
+        <p:spPr>
+          <a:xfrm>
+            <a:off x="548640" y="2788920"/>
+            <a:ext cx="2103120" cy="411480"/>
           </a:xfrm>
           <a:prstGeom prst="rect">
             <a:avLst/>
@@ -7751,7 +7423,7 @@
                 <a:ea typeface="Trebuchet MS" pitchFamily="34" charset="-122"/>
                 <a:cs typeface="Trebuchet MS" pitchFamily="34" charset="-120"/>
               </a:rPr>
-              <a:t>SHOW CREATE TABLE</a:t>
+              <a:t>Nommage</a:t>
             </a:r>
             <a:endParaRPr lang="en-US" sz="900" dirty="0"/>
           </a:p>
@@ -7759,34 +7431,34 @@
       </p:sp>
       <p:sp>
         <p:nvSpPr>
-          <p:cNvPr id="23" name="Shape 21"/>
-          <p:cNvSpPr/>
-          <p:nvPr/>
-        </p:nvSpPr>
-        <p:spPr>
-          <a:xfrm>
-            <a:off x="2743200" y="2971800"/>
-            <a:ext cx="5943600" cy="475488"/>
-          </a:xfrm>
-          <a:prstGeom prst="rect">
-            <a:avLst/>
-          </a:prstGeom>
-          <a:solidFill>
-            <a:srgbClr val="E3F2FD"/>
-          </a:solidFill>
-          <a:ln/>
-        </p:spPr>
-      </p:sp>
-      <p:sp>
-        <p:nvSpPr>
-          <p:cNvPr id="24" name="Text 22"/>
-          <p:cNvSpPr/>
-          <p:nvPr/>
-        </p:nvSpPr>
-        <p:spPr>
-          <a:xfrm>
-            <a:off x="2834640" y="2971800"/>
-            <a:ext cx="5760720" cy="475488"/>
+          <p:cNvPr id="25" name="Shape 23"/>
+          <p:cNvSpPr/>
+          <p:nvPr/>
+        </p:nvSpPr>
+        <p:spPr>
+          <a:xfrm>
+            <a:off x="2743200" y="2788920"/>
+            <a:ext cx="5943600" cy="411480"/>
+          </a:xfrm>
+          <a:prstGeom prst="rect">
+            <a:avLst/>
+          </a:prstGeom>
+          <a:solidFill>
+            <a:srgbClr val="F0F0F0"/>
+          </a:solidFill>
+          <a:ln/>
+        </p:spPr>
+      </p:sp>
+      <p:sp>
+        <p:nvSpPr>
+          <p:cNvPr id="26" name="Text 24"/>
+          <p:cNvSpPr/>
+          <p:nvPr/>
+        </p:nvSpPr>
+        <p:spPr>
+          <a:xfrm>
+            <a:off x="2834640" y="2788920"/>
+            <a:ext cx="5760720" cy="411480"/>
           </a:xfrm>
           <a:prstGeom prst="rect">
             <a:avLst/>
@@ -7810,7 +7482,7 @@
                 <a:ea typeface="Calibri" pitchFamily="34" charset="-122"/>
                 <a:cs typeface="Calibri" pitchFamily="34" charset="-120"/>
               </a:rPr>
-              <a:t>Voir la structure complète d'une table</a:t>
+              <a:t>Minuscules, underscores, prefixes (fk_, chk_)</a:t>
             </a:r>
             <a:endParaRPr lang="en-US" sz="900" dirty="0"/>
           </a:p>
@@ -7818,34 +7490,34 @@
       </p:sp>
       <p:sp>
         <p:nvSpPr>
-          <p:cNvPr id="25" name="Shape 23"/>
-          <p:cNvSpPr/>
-          <p:nvPr/>
-        </p:nvSpPr>
-        <p:spPr>
-          <a:xfrm>
-            <a:off x="457200" y="3474720"/>
-            <a:ext cx="2286000" cy="475488"/>
-          </a:xfrm>
-          <a:prstGeom prst="rect">
-            <a:avLst/>
-          </a:prstGeom>
-          <a:solidFill>
-            <a:srgbClr val="F0F0F0"/>
-          </a:solidFill>
-          <a:ln/>
-        </p:spPr>
-      </p:sp>
-      <p:sp>
-        <p:nvSpPr>
-          <p:cNvPr id="26" name="Text 24"/>
-          <p:cNvSpPr/>
-          <p:nvPr/>
-        </p:nvSpPr>
-        <p:spPr>
-          <a:xfrm>
-            <a:off x="548640" y="3474720"/>
-            <a:ext cx="2103120" cy="475488"/>
+          <p:cNvPr id="27" name="Shape 25"/>
+          <p:cNvSpPr/>
+          <p:nvPr/>
+        </p:nvSpPr>
+        <p:spPr>
+          <a:xfrm>
+            <a:off x="457200" y="3227832"/>
+            <a:ext cx="2286000" cy="411480"/>
+          </a:xfrm>
+          <a:prstGeom prst="rect">
+            <a:avLst/>
+          </a:prstGeom>
+          <a:solidFill>
+            <a:srgbClr val="E3F2FD"/>
+          </a:solidFill>
+          <a:ln/>
+        </p:spPr>
+      </p:sp>
+      <p:sp>
+        <p:nvSpPr>
+          <p:cNvPr id="28" name="Text 26"/>
+          <p:cNvSpPr/>
+          <p:nvPr/>
+        </p:nvSpPr>
+        <p:spPr>
+          <a:xfrm>
+            <a:off x="548640" y="3227832"/>
+            <a:ext cx="2103120" cy="411480"/>
           </a:xfrm>
           <a:prstGeom prst="rect">
             <a:avLst/>
@@ -7869,7 +7541,7 @@
                 <a:ea typeface="Trebuchet MS" pitchFamily="34" charset="-122"/>
                 <a:cs typeface="Trebuchet MS" pitchFamily="34" charset="-120"/>
               </a:rPr>
-              <a:t>Nommage</a:t>
+              <a:t>COMMENT</a:t>
             </a:r>
             <a:endParaRPr lang="en-US" sz="900" dirty="0"/>
           </a:p>
@@ -7877,34 +7549,34 @@
       </p:sp>
       <p:sp>
         <p:nvSpPr>
-          <p:cNvPr id="27" name="Shape 25"/>
-          <p:cNvSpPr/>
-          <p:nvPr/>
-        </p:nvSpPr>
-        <p:spPr>
-          <a:xfrm>
-            <a:off x="2743200" y="3474720"/>
-            <a:ext cx="5943600" cy="475488"/>
-          </a:xfrm>
-          <a:prstGeom prst="rect">
-            <a:avLst/>
-          </a:prstGeom>
-          <a:solidFill>
-            <a:srgbClr val="F0F0F0"/>
-          </a:solidFill>
-          <a:ln/>
-        </p:spPr>
-      </p:sp>
-      <p:sp>
-        <p:nvSpPr>
-          <p:cNvPr id="28" name="Text 26"/>
-          <p:cNvSpPr/>
-          <p:nvPr/>
-        </p:nvSpPr>
-        <p:spPr>
-          <a:xfrm>
-            <a:off x="2834640" y="3474720"/>
-            <a:ext cx="5760720" cy="475488"/>
+          <p:cNvPr id="29" name="Shape 27"/>
+          <p:cNvSpPr/>
+          <p:nvPr/>
+        </p:nvSpPr>
+        <p:spPr>
+          <a:xfrm>
+            <a:off x="2743200" y="3227832"/>
+            <a:ext cx="5943600" cy="411480"/>
+          </a:xfrm>
+          <a:prstGeom prst="rect">
+            <a:avLst/>
+          </a:prstGeom>
+          <a:solidFill>
+            <a:srgbClr val="E3F2FD"/>
+          </a:solidFill>
+          <a:ln/>
+        </p:spPr>
+      </p:sp>
+      <p:sp>
+        <p:nvSpPr>
+          <p:cNvPr id="30" name="Text 28"/>
+          <p:cNvSpPr/>
+          <p:nvPr/>
+        </p:nvSpPr>
+        <p:spPr>
+          <a:xfrm>
+            <a:off x="2834640" y="3227832"/>
+            <a:ext cx="5760720" cy="411480"/>
           </a:xfrm>
           <a:prstGeom prst="rect">
             <a:avLst/>
@@ -7928,7 +7600,7 @@
                 <a:ea typeface="Calibri" pitchFamily="34" charset="-122"/>
                 <a:cs typeface="Calibri" pitchFamily="34" charset="-120"/>
               </a:rPr>
-              <a:t>Minuscules, underscores, préfixes contraintes (fk_, chk_)</a:t>
+              <a:t>Documenter chaque table et colonne</a:t>
             </a:r>
             <a:endParaRPr lang="en-US" sz="900" dirty="0"/>
           </a:p>

</xml_diff>